<commit_message>
Add artifacts, instructions, and sources for 15-17 Oct 2026: Giant Sea Wall, PALCapital tokenization, SDA/NRF governance, and Stabilise-Save-Invest-Grow
</commit_message>
<xml_diff>
--- a/artifact/14102026/Infografis_Danantara_Empat_Pilar_Dampak_v2_14102026.pptx
+++ b/artifact/14102026/Infografis_Danantara_Empat_Pilar_Dampak_v2_14102026.pptx
@@ -5,13 +5,13 @@
     <p:sldMasterId id="2147483648" r:id="rId1"/>
   </p:sldMasterIdLst>
   <p:notesMasterIdLst>
-    <p:notesMasterId r:id="rId5"/>
+    <p:notesMasterId r:id="rId6"/>
   </p:notesMasterIdLst>
   <p:sldIdLst>
     <p:sldId id="256" r:id="rId2"/>
     <p:sldId id="257" r:id="rId3"/>
-    <p:sldId id="259" r:id="rId10"/>
-    <p:sldId id="260" r:id="rId11"/>
+    <p:sldId id="259" r:id="rId4"/>
+    <p:sldId id="260" r:id="rId5"/>
   </p:sldIdLst>
   <p:sldSz cx="10688638" cy="7562850"/>
   <p:notesSz cx="7562850" cy="10688638"/>
@@ -1105,7 +1105,40 @@
                 <a:ea typeface="Arial" pitchFamily="34" charset="-122"/>
                 <a:cs typeface="Arial" pitchFamily="34" charset="-120"/>
               </a:rPr>
-              <a:t>Kondisi Danantara saat ini</a:t>
+              <a:t>Mandat </a:t>
+            </a:r>
+            <a:r>
+              <a:rPr lang="en-US" sz="1300" b="1" dirty="0" err="1">
+                <a:solidFill>
+                  <a:srgbClr val="0A0A0A"/>
+                </a:solidFill>
+                <a:latin typeface="Arial" pitchFamily="34" charset="0"/>
+                <a:ea typeface="Arial" pitchFamily="34" charset="-122"/>
+                <a:cs typeface="Arial" pitchFamily="34" charset="-120"/>
+              </a:rPr>
+              <a:t>Industrialisasi</a:t>
+            </a:r>
+            <a:r>
+              <a:rPr lang="en-US" sz="1300" b="1" dirty="0">
+                <a:solidFill>
+                  <a:srgbClr val="0A0A0A"/>
+                </a:solidFill>
+                <a:latin typeface="Arial" pitchFamily="34" charset="0"/>
+                <a:ea typeface="Arial" pitchFamily="34" charset="-122"/>
+                <a:cs typeface="Arial" pitchFamily="34" charset="-120"/>
+              </a:rPr>
+              <a:t> Belum </a:t>
+            </a:r>
+            <a:r>
+              <a:rPr lang="en-US" sz="1300" b="1" dirty="0" err="1">
+                <a:solidFill>
+                  <a:srgbClr val="0A0A0A"/>
+                </a:solidFill>
+                <a:latin typeface="Arial" pitchFamily="34" charset="0"/>
+                <a:ea typeface="Arial" pitchFamily="34" charset="-122"/>
+                <a:cs typeface="Arial" pitchFamily="34" charset="-120"/>
+              </a:rPr>
+              <a:t>Tampak</a:t>
             </a:r>
             <a:endParaRPr lang="en-US" sz="1300" dirty="0"/>
           </a:p>
@@ -1508,7 +1541,7 @@
             <a:r>
               <a:rPr lang="en-US" sz="1400" b="1" dirty="0">
                 <a:solidFill>
-                  <a:srgbClr val="0B57C2"/>
+                  <a:srgbClr val="FF0000"/>
                 </a:solidFill>
                 <a:latin typeface="Arial" pitchFamily="34" charset="0"/>
                 <a:ea typeface="Arial" pitchFamily="34" charset="-122"/>
@@ -1516,7 +1549,11 @@
               </a:rPr>
               <a:t>≈ Rp28 T</a:t>
             </a:r>
-            <a:endParaRPr lang="en-US" sz="1400" dirty="0"/>
+            <a:endParaRPr lang="en-US" sz="1400" dirty="0">
+              <a:solidFill>
+                <a:srgbClr val="FF0000"/>
+              </a:solidFill>
+            </a:endParaRPr>
           </a:p>
         </p:txBody>
       </p:sp>
@@ -2126,7 +2163,7 @@
                 <a:ea typeface="Arial" pitchFamily="34" charset="-122"/>
                 <a:cs typeface="Arial" pitchFamily="34" charset="-120"/>
               </a:rPr>
-              <a:t>40 proyek strategis · Rp2.091 T</a:t>
+              <a:t>40 proyek strategis · Rp 5,XxX T</a:t>
             </a:r>
             <a:endParaRPr lang="en-US" sz="1300" dirty="0"/>
           </a:p>
@@ -2824,7 +2861,7 @@
                 <a:ea typeface="Arial" pitchFamily="34" charset="-122"/>
                 <a:cs typeface="Arial" pitchFamily="34" charset="-120"/>
               </a:rPr>
-              <a:t>Rp1.274,6 T</a:t>
+              <a:t>Rp XXX T</a:t>
             </a:r>
             <a:endParaRPr lang="en-US" sz="1500" dirty="0"/>
           </a:p>
@@ -3210,7 +3247,7 @@
                 <a:ea typeface="Arial" pitchFamily="34" charset="-122"/>
                 <a:cs typeface="Arial" pitchFamily="34" charset="-120"/>
               </a:rPr>
-              <a:t>Rp81,1 T</a:t>
+              <a:t>Rp 2,125 T</a:t>
             </a:r>
             <a:endParaRPr lang="en-US" sz="1500" dirty="0"/>
           </a:p>
@@ -3456,7 +3493,7 @@
                 <a:ea typeface="Arial" pitchFamily="34" charset="-122"/>
                 <a:cs typeface="Arial" pitchFamily="34" charset="-120"/>
               </a:rPr>
-              <a:t>Rp25,6 T</a:t>
+              <a:t>Rp 200 T</a:t>
             </a:r>
             <a:endParaRPr lang="en-US" sz="1500" dirty="0"/>
           </a:p>
@@ -3495,7 +3532,29 @@
                 <a:ea typeface="Arial" pitchFamily="34" charset="-122"/>
                 <a:cs typeface="Arial" pitchFamily="34" charset="-120"/>
               </a:rPr>
-              <a:t>AI berdaulat Rp13,8 T</a:t>
+              <a:t>AI </a:t>
+            </a:r>
+            <a:r>
+              <a:rPr lang="en-US" sz="750" b="1" dirty="0" err="1">
+                <a:solidFill>
+                  <a:srgbClr val="0A0A0A"/>
+                </a:solidFill>
+                <a:latin typeface="Arial" pitchFamily="34" charset="0"/>
+                <a:ea typeface="Arial" pitchFamily="34" charset="-122"/>
+                <a:cs typeface="Arial" pitchFamily="34" charset="-120"/>
+              </a:rPr>
+              <a:t>berdaulat</a:t>
+            </a:r>
+            <a:r>
+              <a:rPr lang="en-US" sz="750" b="1" dirty="0">
+                <a:solidFill>
+                  <a:srgbClr val="0A0A0A"/>
+                </a:solidFill>
+                <a:latin typeface="Arial" pitchFamily="34" charset="0"/>
+                <a:ea typeface="Arial" pitchFamily="34" charset="-122"/>
+                <a:cs typeface="Arial" pitchFamily="34" charset="-120"/>
+              </a:rPr>
+              <a:t> Rp 50 T</a:t>
             </a:r>
             <a:endParaRPr lang="en-US" sz="750" dirty="0"/>
           </a:p>
@@ -3526,7 +3585,7 @@
               <a:buNone/>
             </a:pPr>
             <a:r>
-              <a:rPr lang="en-US" sz="750" dirty="0">
+              <a:rPr lang="en-US" sz="750" dirty="0" err="1">
                 <a:solidFill>
                   <a:srgbClr val="0A0A0A"/>
                 </a:solidFill>
@@ -3534,7 +3593,40 @@
                 <a:ea typeface="Arial" pitchFamily="34" charset="-122"/>
                 <a:cs typeface="Arial" pitchFamily="34" charset="-120"/>
               </a:rPr>
-              <a:t>Semikonduktor Rp7,1 T, pusat data Rp4,1 T, kuantum Rp0,5 T</a:t>
+              <a:t>Semikonduktor</a:t>
+            </a:r>
+            <a:r>
+              <a:rPr lang="en-US" sz="750" dirty="0">
+                <a:solidFill>
+                  <a:srgbClr val="0A0A0A"/>
+                </a:solidFill>
+                <a:latin typeface="Arial" pitchFamily="34" charset="0"/>
+                <a:ea typeface="Arial" pitchFamily="34" charset="-122"/>
+                <a:cs typeface="Arial" pitchFamily="34" charset="-120"/>
+              </a:rPr>
+              <a:t> Rp 100 T, pusat data Rp 40 T, </a:t>
+            </a:r>
+            <a:r>
+              <a:rPr lang="en-US" sz="750" dirty="0" err="1">
+                <a:solidFill>
+                  <a:srgbClr val="0A0A0A"/>
+                </a:solidFill>
+                <a:latin typeface="Arial" pitchFamily="34" charset="0"/>
+                <a:ea typeface="Arial" pitchFamily="34" charset="-122"/>
+                <a:cs typeface="Arial" pitchFamily="34" charset="-120"/>
+              </a:rPr>
+              <a:t>kuantum</a:t>
+            </a:r>
+            <a:r>
+              <a:rPr lang="en-US" sz="750" dirty="0">
+                <a:solidFill>
+                  <a:srgbClr val="0A0A0A"/>
+                </a:solidFill>
+                <a:latin typeface="Arial" pitchFamily="34" charset="0"/>
+                <a:ea typeface="Arial" pitchFamily="34" charset="-122"/>
+                <a:cs typeface="Arial" pitchFamily="34" charset="-120"/>
+              </a:rPr>
+              <a:t> Rp 10 T</a:t>
             </a:r>
             <a:endParaRPr lang="en-US" sz="750" dirty="0"/>
           </a:p>
@@ -3581,7 +3673,7 @@
       </p:sp>
       <p:sp>
         <p:nvSpPr>
-          <p:cNvPr id="32" name="Shape 29"/>
+          <p:cNvPr id="138" name="Shape 29"/>
           <p:cNvSpPr/>
           <p:nvPr/>
         </p:nvSpPr>
@@ -3654,7 +3746,9 @@
         <p:txBody>
           <a:bodyPr rtlCol="0" anchor="ctr"/>
           <a:lstStyle/>
-          <a:p/>
+          <a:p>
+            <a:endParaRPr/>
+          </a:p>
         </p:txBody>
       </p:sp>
       <p:pic>
@@ -3698,7 +3792,7 @@
           <a:noFill/>
         </p:spPr>
         <p:txBody>
-          <a:bodyPr wrap="square" lIns="0" rIns="0" tIns="0" bIns="0" anchor="ctr">
+          <a:bodyPr wrap="square" lIns="0" tIns="0" rIns="0" bIns="0" anchor="ctr">
             <a:spAutoFit/>
           </a:bodyPr>
           <a:lstStyle/>
@@ -3768,7 +3862,9 @@
         <p:txBody>
           <a:bodyPr rtlCol="0" anchor="ctr"/>
           <a:lstStyle/>
-          <a:p/>
+          <a:p>
+            <a:endParaRPr/>
+          </a:p>
         </p:txBody>
       </p:sp>
       <p:sp>
@@ -3812,7 +3908,9 @@
         <p:txBody>
           <a:bodyPr rtlCol="0" anchor="ctr"/>
           <a:lstStyle/>
-          <a:p/>
+          <a:p>
+            <a:endParaRPr/>
+          </a:p>
         </p:txBody>
       </p:sp>
       <p:pic>
@@ -3856,7 +3954,7 @@
           <a:noFill/>
         </p:spPr>
         <p:txBody>
-          <a:bodyPr wrap="square" lIns="0" rIns="0" tIns="0" bIns="0" anchor="ctr">
+          <a:bodyPr wrap="square" lIns="0" tIns="0" rIns="0" bIns="0" anchor="ctr">
             <a:spAutoFit/>
           </a:bodyPr>
           <a:lstStyle/>
@@ -3891,7 +3989,7 @@
           <a:noFill/>
         </p:spPr>
         <p:txBody>
-          <a:bodyPr wrap="square" lIns="0" rIns="0" tIns="0" bIns="0" anchor="t">
+          <a:bodyPr wrap="square" lIns="0" tIns="0" rIns="0" bIns="0" anchor="t">
             <a:spAutoFit/>
           </a:bodyPr>
           <a:lstStyle/>
@@ -3926,7 +4024,7 @@
           <a:noFill/>
         </p:spPr>
         <p:txBody>
-          <a:bodyPr wrap="square" lIns="0" rIns="0" tIns="0" bIns="0" anchor="ctr">
+          <a:bodyPr wrap="square" lIns="0" tIns="0" rIns="0" bIns="0" anchor="ctr">
             <a:spAutoFit/>
           </a:bodyPr>
           <a:lstStyle/>
@@ -3961,7 +4059,7 @@
           <a:noFill/>
         </p:spPr>
         <p:txBody>
-          <a:bodyPr wrap="square" lIns="0" rIns="0" tIns="0" bIns="0" anchor="t">
+          <a:bodyPr wrap="square" lIns="0" tIns="0" rIns="0" bIns="0" anchor="t">
             <a:spAutoFit/>
           </a:bodyPr>
           <a:lstStyle/>
@@ -3996,7 +4094,7 @@
           <a:noFill/>
         </p:spPr>
         <p:txBody>
-          <a:bodyPr wrap="square" lIns="0" rIns="0" tIns="0" bIns="0" anchor="t">
+          <a:bodyPr wrap="square" lIns="0" tIns="0" rIns="0" bIns="0" anchor="t">
             <a:spAutoFit/>
           </a:bodyPr>
           <a:lstStyle/>
@@ -4057,7 +4155,9 @@
         <p:txBody>
           <a:bodyPr rtlCol="0" anchor="ctr"/>
           <a:lstStyle/>
-          <a:p/>
+          <a:p>
+            <a:endParaRPr/>
+          </a:p>
         </p:txBody>
       </p:sp>
       <p:sp>
@@ -4101,7 +4201,9 @@
         <p:txBody>
           <a:bodyPr rtlCol="0" anchor="ctr"/>
           <a:lstStyle/>
-          <a:p/>
+          <a:p>
+            <a:endParaRPr/>
+          </a:p>
         </p:txBody>
       </p:sp>
       <p:pic>
@@ -4145,7 +4247,7 @@
           <a:noFill/>
         </p:spPr>
         <p:txBody>
-          <a:bodyPr wrap="square" lIns="0" rIns="0" tIns="0" bIns="0" anchor="ctr">
+          <a:bodyPr wrap="square" lIns="0" tIns="0" rIns="0" bIns="0" anchor="ctr">
             <a:spAutoFit/>
           </a:bodyPr>
           <a:lstStyle/>
@@ -4180,7 +4282,7 @@
           <a:noFill/>
         </p:spPr>
         <p:txBody>
-          <a:bodyPr wrap="square" lIns="0" rIns="0" tIns="0" bIns="0" anchor="t">
+          <a:bodyPr wrap="square" lIns="0" tIns="0" rIns="0" bIns="0" anchor="t">
             <a:spAutoFit/>
           </a:bodyPr>
           <a:lstStyle/>
@@ -4215,7 +4317,7 @@
           <a:noFill/>
         </p:spPr>
         <p:txBody>
-          <a:bodyPr wrap="square" lIns="0" rIns="0" tIns="0" bIns="0" anchor="ctr">
+          <a:bodyPr wrap="square" lIns="0" tIns="0" rIns="0" bIns="0" anchor="ctr">
             <a:spAutoFit/>
           </a:bodyPr>
           <a:lstStyle/>
@@ -4250,7 +4352,7 @@
           <a:noFill/>
         </p:spPr>
         <p:txBody>
-          <a:bodyPr wrap="square" lIns="0" rIns="0" tIns="0" bIns="0" anchor="t">
+          <a:bodyPr wrap="square" lIns="0" tIns="0" rIns="0" bIns="0" anchor="t">
             <a:spAutoFit/>
           </a:bodyPr>
           <a:lstStyle/>
@@ -4285,7 +4387,7 @@
           <a:noFill/>
         </p:spPr>
         <p:txBody>
-          <a:bodyPr wrap="square" lIns="0" rIns="0" tIns="0" bIns="0" anchor="t">
+          <a:bodyPr wrap="square" lIns="0" tIns="0" rIns="0" bIns="0" anchor="t">
             <a:spAutoFit/>
           </a:bodyPr>
           <a:lstStyle/>
@@ -4346,7 +4448,9 @@
         <p:txBody>
           <a:bodyPr rtlCol="0" anchor="ctr"/>
           <a:lstStyle/>
-          <a:p/>
+          <a:p>
+            <a:endParaRPr/>
+          </a:p>
         </p:txBody>
       </p:sp>
       <p:sp>
@@ -4390,7 +4494,9 @@
         <p:txBody>
           <a:bodyPr rtlCol="0" anchor="ctr"/>
           <a:lstStyle/>
-          <a:p/>
+          <a:p>
+            <a:endParaRPr/>
+          </a:p>
         </p:txBody>
       </p:sp>
       <p:pic>
@@ -4434,7 +4540,7 @@
           <a:noFill/>
         </p:spPr>
         <p:txBody>
-          <a:bodyPr wrap="square" lIns="0" rIns="0" tIns="0" bIns="0" anchor="ctr">
+          <a:bodyPr wrap="square" lIns="0" tIns="0" rIns="0" bIns="0" anchor="ctr">
             <a:spAutoFit/>
           </a:bodyPr>
           <a:lstStyle/>
@@ -4469,7 +4575,7 @@
           <a:noFill/>
         </p:spPr>
         <p:txBody>
-          <a:bodyPr wrap="square" lIns="0" rIns="0" tIns="0" bIns="0" anchor="t">
+          <a:bodyPr wrap="square" lIns="0" tIns="0" rIns="0" bIns="0" anchor="t">
             <a:spAutoFit/>
           </a:bodyPr>
           <a:lstStyle/>
@@ -4504,7 +4610,7 @@
           <a:noFill/>
         </p:spPr>
         <p:txBody>
-          <a:bodyPr wrap="square" lIns="0" rIns="0" tIns="0" bIns="0" anchor="ctr">
+          <a:bodyPr wrap="square" lIns="0" tIns="0" rIns="0" bIns="0" anchor="ctr">
             <a:spAutoFit/>
           </a:bodyPr>
           <a:lstStyle/>
@@ -4539,7 +4645,7 @@
           <a:noFill/>
         </p:spPr>
         <p:txBody>
-          <a:bodyPr wrap="square" lIns="0" rIns="0" tIns="0" bIns="0" anchor="t">
+          <a:bodyPr wrap="square" lIns="0" tIns="0" rIns="0" bIns="0" anchor="t">
             <a:spAutoFit/>
           </a:bodyPr>
           <a:lstStyle/>
@@ -4574,7 +4680,7 @@
           <a:noFill/>
         </p:spPr>
         <p:txBody>
-          <a:bodyPr wrap="square" lIns="0" rIns="0" tIns="0" bIns="0" anchor="t">
+          <a:bodyPr wrap="square" lIns="0" tIns="0" rIns="0" bIns="0" anchor="t">
             <a:spAutoFit/>
           </a:bodyPr>
           <a:lstStyle/>
@@ -4635,7 +4741,9 @@
         <p:txBody>
           <a:bodyPr rtlCol="0" anchor="ctr"/>
           <a:lstStyle/>
-          <a:p/>
+          <a:p>
+            <a:endParaRPr/>
+          </a:p>
         </p:txBody>
       </p:sp>
       <p:sp>
@@ -4679,7 +4787,9 @@
         <p:txBody>
           <a:bodyPr rtlCol="0" anchor="ctr"/>
           <a:lstStyle/>
-          <a:p/>
+          <a:p>
+            <a:endParaRPr/>
+          </a:p>
         </p:txBody>
       </p:sp>
       <p:pic>
@@ -4723,7 +4833,7 @@
           <a:noFill/>
         </p:spPr>
         <p:txBody>
-          <a:bodyPr wrap="square" lIns="0" rIns="0" tIns="0" bIns="0" anchor="ctr">
+          <a:bodyPr wrap="square" lIns="0" tIns="0" rIns="0" bIns="0" anchor="ctr">
             <a:spAutoFit/>
           </a:bodyPr>
           <a:lstStyle/>
@@ -4758,7 +4868,7 @@
           <a:noFill/>
         </p:spPr>
         <p:txBody>
-          <a:bodyPr wrap="square" lIns="0" rIns="0" tIns="0" bIns="0" anchor="t">
+          <a:bodyPr wrap="square" lIns="0" tIns="0" rIns="0" bIns="0" anchor="t">
             <a:spAutoFit/>
           </a:bodyPr>
           <a:lstStyle/>
@@ -4793,7 +4903,7 @@
           <a:noFill/>
         </p:spPr>
         <p:txBody>
-          <a:bodyPr wrap="square" lIns="0" rIns="0" tIns="0" bIns="0" anchor="ctr">
+          <a:bodyPr wrap="square" lIns="0" tIns="0" rIns="0" bIns="0" anchor="ctr">
             <a:spAutoFit/>
           </a:bodyPr>
           <a:lstStyle/>
@@ -4828,7 +4938,7 @@
           <a:noFill/>
         </p:spPr>
         <p:txBody>
-          <a:bodyPr wrap="square" lIns="0" rIns="0" tIns="0" bIns="0" anchor="t">
+          <a:bodyPr wrap="square" lIns="0" tIns="0" rIns="0" bIns="0" anchor="t">
             <a:spAutoFit/>
           </a:bodyPr>
           <a:lstStyle/>
@@ -4863,7 +4973,7 @@
           <a:noFill/>
         </p:spPr>
         <p:txBody>
-          <a:bodyPr wrap="square" lIns="0" rIns="0" tIns="0" bIns="0" anchor="t">
+          <a:bodyPr wrap="square" lIns="0" tIns="0" rIns="0" bIns="0" anchor="t">
             <a:spAutoFit/>
           </a:bodyPr>
           <a:lstStyle/>
@@ -4924,7 +5034,9 @@
         <p:txBody>
           <a:bodyPr rtlCol="0" anchor="ctr"/>
           <a:lstStyle/>
-          <a:p/>
+          <a:p>
+            <a:endParaRPr/>
+          </a:p>
         </p:txBody>
       </p:sp>
       <p:sp>
@@ -4968,7 +5080,9 @@
         <p:txBody>
           <a:bodyPr rtlCol="0" anchor="ctr"/>
           <a:lstStyle/>
-          <a:p/>
+          <a:p>
+            <a:endParaRPr/>
+          </a:p>
         </p:txBody>
       </p:sp>
       <p:pic>
@@ -5012,7 +5126,7 @@
           <a:noFill/>
         </p:spPr>
         <p:txBody>
-          <a:bodyPr wrap="square" lIns="0" rIns="0" tIns="0" bIns="0" anchor="ctr">
+          <a:bodyPr wrap="square" lIns="0" tIns="0" rIns="0" bIns="0" anchor="ctr">
             <a:spAutoFit/>
           </a:bodyPr>
           <a:lstStyle/>
@@ -5047,7 +5161,7 @@
           <a:noFill/>
         </p:spPr>
         <p:txBody>
-          <a:bodyPr wrap="square" lIns="0" rIns="0" tIns="0" bIns="0" anchor="t">
+          <a:bodyPr wrap="square" lIns="0" tIns="0" rIns="0" bIns="0" anchor="t">
             <a:spAutoFit/>
           </a:bodyPr>
           <a:lstStyle/>
@@ -5082,7 +5196,7 @@
           <a:noFill/>
         </p:spPr>
         <p:txBody>
-          <a:bodyPr wrap="square" lIns="0" rIns="0" tIns="0" bIns="0" anchor="ctr">
+          <a:bodyPr wrap="square" lIns="0" tIns="0" rIns="0" bIns="0" anchor="ctr">
             <a:spAutoFit/>
           </a:bodyPr>
           <a:lstStyle/>
@@ -5117,7 +5231,7 @@
           <a:noFill/>
         </p:spPr>
         <p:txBody>
-          <a:bodyPr wrap="square" lIns="0" rIns="0" tIns="0" bIns="0" anchor="t">
+          <a:bodyPr wrap="square" lIns="0" tIns="0" rIns="0" bIns="0" anchor="t">
             <a:spAutoFit/>
           </a:bodyPr>
           <a:lstStyle/>
@@ -5152,7 +5266,7 @@
           <a:noFill/>
         </p:spPr>
         <p:txBody>
-          <a:bodyPr wrap="square" lIns="0" rIns="0" tIns="0" bIns="0" anchor="t">
+          <a:bodyPr wrap="square" lIns="0" tIns="0" rIns="0" bIns="0" anchor="t">
             <a:spAutoFit/>
           </a:bodyPr>
           <a:lstStyle/>
@@ -5213,7 +5327,9 @@
         <p:txBody>
           <a:bodyPr rtlCol="0" anchor="ctr"/>
           <a:lstStyle/>
-          <a:p/>
+          <a:p>
+            <a:endParaRPr/>
+          </a:p>
         </p:txBody>
       </p:sp>
       <p:sp>
@@ -5257,7 +5373,9 @@
         <p:txBody>
           <a:bodyPr rtlCol="0" anchor="ctr"/>
           <a:lstStyle/>
-          <a:p/>
+          <a:p>
+            <a:endParaRPr/>
+          </a:p>
         </p:txBody>
       </p:sp>
       <p:pic>
@@ -5301,7 +5419,7 @@
           <a:noFill/>
         </p:spPr>
         <p:txBody>
-          <a:bodyPr wrap="square" lIns="0" rIns="0" tIns="0" bIns="0" anchor="ctr">
+          <a:bodyPr wrap="square" lIns="0" tIns="0" rIns="0" bIns="0" anchor="ctr">
             <a:spAutoFit/>
           </a:bodyPr>
           <a:lstStyle/>
@@ -5336,7 +5454,7 @@
           <a:noFill/>
         </p:spPr>
         <p:txBody>
-          <a:bodyPr wrap="square" lIns="0" rIns="0" tIns="0" bIns="0" anchor="t">
+          <a:bodyPr wrap="square" lIns="0" tIns="0" rIns="0" bIns="0" anchor="t">
             <a:spAutoFit/>
           </a:bodyPr>
           <a:lstStyle/>
@@ -5371,7 +5489,7 @@
           <a:noFill/>
         </p:spPr>
         <p:txBody>
-          <a:bodyPr wrap="square" lIns="0" rIns="0" tIns="0" bIns="0" anchor="ctr">
+          <a:bodyPr wrap="square" lIns="0" tIns="0" rIns="0" bIns="0" anchor="ctr">
             <a:spAutoFit/>
           </a:bodyPr>
           <a:lstStyle/>
@@ -5406,7 +5524,7 @@
           <a:noFill/>
         </p:spPr>
         <p:txBody>
-          <a:bodyPr wrap="square" lIns="0" rIns="0" tIns="0" bIns="0" anchor="t">
+          <a:bodyPr wrap="square" lIns="0" tIns="0" rIns="0" bIns="0" anchor="t">
             <a:spAutoFit/>
           </a:bodyPr>
           <a:lstStyle/>
@@ -5441,7 +5559,7 @@
           <a:noFill/>
         </p:spPr>
         <p:txBody>
-          <a:bodyPr wrap="square" lIns="0" rIns="0" tIns="0" bIns="0" anchor="t">
+          <a:bodyPr wrap="square" lIns="0" tIns="0" rIns="0" bIns="0" anchor="t">
             <a:spAutoFit/>
           </a:bodyPr>
           <a:lstStyle/>
@@ -5502,7 +5620,9 @@
         <p:txBody>
           <a:bodyPr rtlCol="0" anchor="ctr"/>
           <a:lstStyle/>
-          <a:p/>
+          <a:p>
+            <a:endParaRPr/>
+          </a:p>
         </p:txBody>
       </p:sp>
       <p:sp>
@@ -5546,7 +5666,9 @@
         <p:txBody>
           <a:bodyPr rtlCol="0" anchor="ctr"/>
           <a:lstStyle/>
-          <a:p/>
+          <a:p>
+            <a:endParaRPr/>
+          </a:p>
         </p:txBody>
       </p:sp>
       <p:pic>
@@ -5590,7 +5712,7 @@
           <a:noFill/>
         </p:spPr>
         <p:txBody>
-          <a:bodyPr wrap="square" lIns="0" rIns="0" tIns="0" bIns="0" anchor="ctr">
+          <a:bodyPr wrap="square" lIns="0" tIns="0" rIns="0" bIns="0" anchor="ctr">
             <a:spAutoFit/>
           </a:bodyPr>
           <a:lstStyle/>
@@ -5625,7 +5747,7 @@
           <a:noFill/>
         </p:spPr>
         <p:txBody>
-          <a:bodyPr wrap="square" lIns="0" rIns="0" tIns="0" bIns="0" anchor="t">
+          <a:bodyPr wrap="square" lIns="0" tIns="0" rIns="0" bIns="0" anchor="t">
             <a:spAutoFit/>
           </a:bodyPr>
           <a:lstStyle/>
@@ -5660,7 +5782,7 @@
           <a:noFill/>
         </p:spPr>
         <p:txBody>
-          <a:bodyPr wrap="square" lIns="0" rIns="0" tIns="0" bIns="0" anchor="ctr">
+          <a:bodyPr wrap="square" lIns="0" tIns="0" rIns="0" bIns="0" anchor="ctr">
             <a:spAutoFit/>
           </a:bodyPr>
           <a:lstStyle/>
@@ -5695,7 +5817,7 @@
           <a:noFill/>
         </p:spPr>
         <p:txBody>
-          <a:bodyPr wrap="square" lIns="0" rIns="0" tIns="0" bIns="0" anchor="t">
+          <a:bodyPr wrap="square" lIns="0" tIns="0" rIns="0" bIns="0" anchor="t">
             <a:spAutoFit/>
           </a:bodyPr>
           <a:lstStyle/>
@@ -5730,7 +5852,7 @@
           <a:noFill/>
         </p:spPr>
         <p:txBody>
-          <a:bodyPr wrap="square" lIns="0" rIns="0" tIns="0" bIns="0" anchor="t">
+          <a:bodyPr wrap="square" lIns="0" tIns="0" rIns="0" bIns="0" anchor="t">
             <a:spAutoFit/>
           </a:bodyPr>
           <a:lstStyle/>
@@ -5791,7 +5913,9 @@
         <p:txBody>
           <a:bodyPr rtlCol="0" anchor="ctr"/>
           <a:lstStyle/>
-          <a:p/>
+          <a:p>
+            <a:endParaRPr/>
+          </a:p>
         </p:txBody>
       </p:sp>
       <p:sp>
@@ -5811,7 +5935,7 @@
           <a:noFill/>
         </p:spPr>
         <p:txBody>
-          <a:bodyPr wrap="square" lIns="0" rIns="0" tIns="0" bIns="0" anchor="ctr">
+          <a:bodyPr wrap="square" lIns="0" tIns="0" rIns="0" bIns="0" anchor="ctr">
             <a:spAutoFit/>
           </a:bodyPr>
           <a:lstStyle/>
@@ -7818,7 +7942,7 @@
 </file>
 
 <file path=ppt/slides/slide3.xml><?xml version="1.0" encoding="utf-8"?>
-<p:sld xmlns:a="http://schemas.openxmlformats.org/drawingml/2006/main" xmlns:p="http://schemas.openxmlformats.org/presentationml/2006/main" xmlns:r="http://schemas.openxmlformats.org/officeDocument/2006/relationships">
+<p:sld xmlns:a="http://schemas.openxmlformats.org/drawingml/2006/main" xmlns:r="http://schemas.openxmlformats.org/officeDocument/2006/relationships" xmlns:p="http://schemas.openxmlformats.org/presentationml/2006/main">
   <p:cSld>
     <p:spTree>
       <p:nvGrpSpPr>
@@ -7826,7 +7950,14 @@
         <p:cNvGrpSpPr/>
         <p:nvPr/>
       </p:nvGrpSpPr>
-      <p:grpSpPr/>
+      <p:grpSpPr>
+        <a:xfrm>
+          <a:off x="0" y="0"/>
+          <a:ext cx="0" cy="0"/>
+          <a:chOff x="0" y="0"/>
+          <a:chExt cx="0" cy="0"/>
+        </a:xfrm>
+      </p:grpSpPr>
       <p:sp>
         <p:nvSpPr>
           <p:cNvPr id="2" name="Text 0"/>
@@ -8019,7 +8150,9 @@
         <p:txBody>
           <a:bodyPr rtlCol="0" anchor="ctr"/>
           <a:lstStyle/>
-          <a:p/>
+          <a:p>
+            <a:endParaRPr/>
+          </a:p>
         </p:txBody>
       </p:sp>
       <p:sp>
@@ -8063,7 +8196,9 @@
         <p:txBody>
           <a:bodyPr rtlCol="0" anchor="ctr"/>
           <a:lstStyle/>
-          <a:p/>
+          <a:p>
+            <a:endParaRPr/>
+          </a:p>
         </p:txBody>
       </p:sp>
       <p:pic>
@@ -8107,7 +8242,7 @@
           <a:noFill/>
         </p:spPr>
         <p:txBody>
-          <a:bodyPr wrap="square" lIns="0" rIns="0" tIns="0" bIns="0" anchor="ctr">
+          <a:bodyPr wrap="square" lIns="0" tIns="0" rIns="0" bIns="0" anchor="ctr">
             <a:spAutoFit/>
           </a:bodyPr>
           <a:lstStyle/>
@@ -8142,7 +8277,7 @@
           <a:noFill/>
         </p:spPr>
         <p:txBody>
-          <a:bodyPr wrap="square" lIns="0" rIns="0" tIns="0" bIns="0" anchor="ctr">
+          <a:bodyPr wrap="square" lIns="0" tIns="0" rIns="0" bIns="0" anchor="ctr">
             <a:spAutoFit/>
           </a:bodyPr>
           <a:lstStyle/>
@@ -8177,7 +8312,7 @@
           <a:noFill/>
         </p:spPr>
         <p:txBody>
-          <a:bodyPr wrap="square" lIns="0" rIns="0" tIns="0" bIns="0" anchor="t">
+          <a:bodyPr wrap="square" lIns="0" tIns="0" rIns="0" bIns="0" anchor="t">
             <a:spAutoFit/>
           </a:bodyPr>
           <a:lstStyle/>
@@ -8238,7 +8373,9 @@
         <p:txBody>
           <a:bodyPr rtlCol="0" anchor="ctr"/>
           <a:lstStyle/>
-          <a:p/>
+          <a:p>
+            <a:endParaRPr/>
+          </a:p>
         </p:txBody>
       </p:sp>
       <p:sp>
@@ -8282,7 +8419,9 @@
         <p:txBody>
           <a:bodyPr rtlCol="0" anchor="ctr"/>
           <a:lstStyle/>
-          <a:p/>
+          <a:p>
+            <a:endParaRPr/>
+          </a:p>
         </p:txBody>
       </p:sp>
       <p:pic>
@@ -8326,7 +8465,7 @@
           <a:noFill/>
         </p:spPr>
         <p:txBody>
-          <a:bodyPr wrap="square" lIns="0" rIns="0" tIns="0" bIns="0" anchor="ctr">
+          <a:bodyPr wrap="square" lIns="0" tIns="0" rIns="0" bIns="0" anchor="ctr">
             <a:spAutoFit/>
           </a:bodyPr>
           <a:lstStyle/>
@@ -8352,29 +8491,47 @@
         </p:nvSpPr>
         <p:spPr>
           <a:xfrm>
-            <a:off x="411479" y="2964688"/>
-            <a:ext cx="1371600" cy="219456"/>
-          </a:xfrm>
-          <a:prstGeom prst="rect">
-            <a:avLst/>
-          </a:prstGeom>
-          <a:noFill/>
-        </p:spPr>
-        <p:txBody>
-          <a:bodyPr wrap="square" lIns="0" rIns="0" tIns="0" bIns="0" anchor="ctr">
+            <a:off x="411479" y="2974388"/>
+            <a:ext cx="1371600" cy="200055"/>
+          </a:xfrm>
+          <a:prstGeom prst="rect">
+            <a:avLst/>
+          </a:prstGeom>
+          <a:noFill/>
+        </p:spPr>
+        <p:txBody>
+          <a:bodyPr wrap="square" lIns="0" tIns="0" rIns="0" bIns="0" anchor="ctr">
             <a:spAutoFit/>
           </a:bodyPr>
           <a:lstStyle/>
           <a:p>
             <a:pPr algn="l"/>
             <a:r>
-              <a:rPr sz="1300" b="1">
+              <a:rPr sz="1300" b="1" dirty="0">
                 <a:solidFill>
                   <a:srgbClr val="FFFFFF"/>
                 </a:solidFill>
                 <a:latin typeface="Arial"/>
               </a:rPr>
-              <a:t>Rp1.274,6 T</a:t>
+              <a:t>Rp</a:t>
+            </a:r>
+            <a:r>
+              <a:rPr lang="en-US" sz="1300" b="1" dirty="0">
+                <a:solidFill>
+                  <a:srgbClr val="FFFFFF"/>
+                </a:solidFill>
+                <a:latin typeface="Arial"/>
+              </a:rPr>
+              <a:t> XXX</a:t>
+            </a:r>
+            <a:r>
+              <a:rPr sz="1300" b="1" dirty="0">
+                <a:solidFill>
+                  <a:srgbClr val="FFFFFF"/>
+                </a:solidFill>
+                <a:latin typeface="Arial"/>
+              </a:rPr>
+              <a:t> T</a:t>
             </a:r>
           </a:p>
         </p:txBody>
@@ -8396,7 +8553,7 @@
           <a:noFill/>
         </p:spPr>
         <p:txBody>
-          <a:bodyPr wrap="square" lIns="0" rIns="0" tIns="0" bIns="0" anchor="t">
+          <a:bodyPr wrap="square" lIns="0" tIns="0" rIns="0" bIns="0" anchor="t">
             <a:spAutoFit/>
           </a:bodyPr>
           <a:lstStyle/>
@@ -8457,7 +8614,9 @@
         <p:txBody>
           <a:bodyPr rtlCol="0" anchor="ctr"/>
           <a:lstStyle/>
-          <a:p/>
+          <a:p>
+            <a:endParaRPr/>
+          </a:p>
         </p:txBody>
       </p:sp>
       <p:sp>
@@ -8501,7 +8660,9 @@
         <p:txBody>
           <a:bodyPr rtlCol="0" anchor="ctr"/>
           <a:lstStyle/>
-          <a:p/>
+          <a:p>
+            <a:endParaRPr/>
+          </a:p>
         </p:txBody>
       </p:sp>
       <p:pic>
@@ -8545,7 +8706,7 @@
           <a:noFill/>
         </p:spPr>
         <p:txBody>
-          <a:bodyPr wrap="square" lIns="0" rIns="0" tIns="0" bIns="0" anchor="ctr">
+          <a:bodyPr wrap="square" lIns="0" tIns="0" rIns="0" bIns="0" anchor="ctr">
             <a:spAutoFit/>
           </a:bodyPr>
           <a:lstStyle/>
@@ -8571,29 +8732,47 @@
         </p:nvSpPr>
         <p:spPr>
           <a:xfrm>
-            <a:off x="411479" y="3981196"/>
-            <a:ext cx="1371600" cy="219456"/>
-          </a:xfrm>
-          <a:prstGeom prst="rect">
-            <a:avLst/>
-          </a:prstGeom>
-          <a:noFill/>
-        </p:spPr>
-        <p:txBody>
-          <a:bodyPr wrap="square" lIns="0" rIns="0" tIns="0" bIns="0" anchor="ctr">
+            <a:off x="411479" y="3990896"/>
+            <a:ext cx="1371600" cy="200055"/>
+          </a:xfrm>
+          <a:prstGeom prst="rect">
+            <a:avLst/>
+          </a:prstGeom>
+          <a:noFill/>
+        </p:spPr>
+        <p:txBody>
+          <a:bodyPr wrap="square" lIns="0" tIns="0" rIns="0" bIns="0" anchor="ctr">
             <a:spAutoFit/>
           </a:bodyPr>
           <a:lstStyle/>
           <a:p>
             <a:pPr algn="l"/>
             <a:r>
-              <a:rPr sz="1300" b="1">
+              <a:rPr sz="1300" b="1" dirty="0">
                 <a:solidFill>
                   <a:srgbClr val="FFFFFF"/>
                 </a:solidFill>
                 <a:latin typeface="Arial"/>
               </a:rPr>
-              <a:t>Rp81,1 T</a:t>
+              <a:t>Rp</a:t>
+            </a:r>
+            <a:r>
+              <a:rPr lang="en-US" sz="1300" b="1" dirty="0">
+                <a:solidFill>
+                  <a:srgbClr val="FFFFFF"/>
+                </a:solidFill>
+                <a:latin typeface="Arial"/>
+              </a:rPr>
+              <a:t> XXX</a:t>
+            </a:r>
+            <a:r>
+              <a:rPr sz="1300" b="1" dirty="0">
+                <a:solidFill>
+                  <a:srgbClr val="FFFFFF"/>
+                </a:solidFill>
+                <a:latin typeface="Arial"/>
+              </a:rPr>
+              <a:t> T</a:t>
             </a:r>
           </a:p>
         </p:txBody>
@@ -8615,7 +8794,7 @@
           <a:noFill/>
         </p:spPr>
         <p:txBody>
-          <a:bodyPr wrap="square" lIns="0" rIns="0" tIns="0" bIns="0" anchor="t">
+          <a:bodyPr wrap="square" lIns="0" tIns="0" rIns="0" bIns="0" anchor="t">
             <a:spAutoFit/>
           </a:bodyPr>
           <a:lstStyle/>
@@ -8676,7 +8855,9 @@
         <p:txBody>
           <a:bodyPr rtlCol="0" anchor="ctr"/>
           <a:lstStyle/>
-          <a:p/>
+          <a:p>
+            <a:endParaRPr/>
+          </a:p>
         </p:txBody>
       </p:sp>
       <p:sp>
@@ -8720,7 +8901,9 @@
         <p:txBody>
           <a:bodyPr rtlCol="0" anchor="ctr"/>
           <a:lstStyle/>
-          <a:p/>
+          <a:p>
+            <a:endParaRPr/>
+          </a:p>
         </p:txBody>
       </p:sp>
       <p:pic>
@@ -8764,7 +8947,7 @@
           <a:noFill/>
         </p:spPr>
         <p:txBody>
-          <a:bodyPr wrap="square" lIns="0" rIns="0" tIns="0" bIns="0" anchor="ctr">
+          <a:bodyPr wrap="square" lIns="0" tIns="0" rIns="0" bIns="0" anchor="ctr">
             <a:spAutoFit/>
           </a:bodyPr>
           <a:lstStyle/>
@@ -8790,29 +8973,47 @@
         </p:nvSpPr>
         <p:spPr>
           <a:xfrm>
-            <a:off x="411479" y="4997704"/>
-            <a:ext cx="1371600" cy="219456"/>
-          </a:xfrm>
-          <a:prstGeom prst="rect">
-            <a:avLst/>
-          </a:prstGeom>
-          <a:noFill/>
-        </p:spPr>
-        <p:txBody>
-          <a:bodyPr wrap="square" lIns="0" rIns="0" tIns="0" bIns="0" anchor="ctr">
+            <a:off x="411479" y="5007404"/>
+            <a:ext cx="1371600" cy="200055"/>
+          </a:xfrm>
+          <a:prstGeom prst="rect">
+            <a:avLst/>
+          </a:prstGeom>
+          <a:noFill/>
+        </p:spPr>
+        <p:txBody>
+          <a:bodyPr wrap="square" lIns="0" tIns="0" rIns="0" bIns="0" anchor="ctr">
             <a:spAutoFit/>
           </a:bodyPr>
           <a:lstStyle/>
           <a:p>
             <a:pPr algn="l"/>
             <a:r>
-              <a:rPr sz="1300" b="1">
+              <a:rPr sz="1300" b="1" dirty="0">
                 <a:solidFill>
                   <a:srgbClr val="FFFFFF"/>
                 </a:solidFill>
                 <a:latin typeface="Arial"/>
               </a:rPr>
-              <a:t>Rp25,6 T</a:t>
+              <a:t>Rp</a:t>
+            </a:r>
+            <a:r>
+              <a:rPr lang="en-US" sz="1300" b="1" dirty="0">
+                <a:solidFill>
+                  <a:srgbClr val="FFFFFF"/>
+                </a:solidFill>
+                <a:latin typeface="Arial"/>
+              </a:rPr>
+              <a:t> XXX</a:t>
+            </a:r>
+            <a:r>
+              <a:rPr sz="1300" b="1" dirty="0">
+                <a:solidFill>
+                  <a:srgbClr val="FFFFFF"/>
+                </a:solidFill>
+                <a:latin typeface="Arial"/>
+              </a:rPr>
+              <a:t> T</a:t>
             </a:r>
           </a:p>
         </p:txBody>
@@ -8834,7 +9035,7 @@
           <a:noFill/>
         </p:spPr>
         <p:txBody>
-          <a:bodyPr wrap="square" lIns="0" rIns="0" tIns="0" bIns="0" anchor="t">
+          <a:bodyPr wrap="square" lIns="0" tIns="0" rIns="0" bIns="0" anchor="t">
             <a:spAutoFit/>
           </a:bodyPr>
           <a:lstStyle/>
@@ -8852,16 +9053,225 @@
           </a:p>
         </p:txBody>
       </p:sp>
-      <p:sp>
-        <p:nvSpPr>
-          <p:cNvPr id="30" name="Rounded Rectangle 29"/>
+      <p:grpSp>
+        <p:nvGrpSpPr>
+          <p:cNvPr id="128" name="Group 127">
+            <a:extLst>
+              <a:ext uri="{FF2B5EF4-FFF2-40B4-BE49-F238E27FC236}">
+                <a16:creationId xmlns:a16="http://schemas.microsoft.com/office/drawing/2014/main" id="{A96065E2-49D2-B2CA-DA77-10F4AFCF7C77}"/>
+              </a:ext>
+            </a:extLst>
+          </p:cNvPr>
+          <p:cNvGrpSpPr/>
+          <p:nvPr/>
+        </p:nvGrpSpPr>
+        <p:grpSpPr>
+          <a:xfrm>
+            <a:off x="2194560" y="892678"/>
+            <a:ext cx="1645920" cy="932688"/>
+            <a:chOff x="2194560" y="1517904"/>
+            <a:chExt cx="1645920" cy="932688"/>
+          </a:xfrm>
+        </p:grpSpPr>
+        <p:sp>
+          <p:nvSpPr>
+            <p:cNvPr id="30" name="Rounded Rectangle 29"/>
+            <p:cNvSpPr/>
+            <p:nvPr/>
+          </p:nvSpPr>
+          <p:spPr>
+            <a:xfrm>
+              <a:off x="2194560" y="1517904"/>
+              <a:ext cx="1645920" cy="932688"/>
+            </a:xfrm>
+            <a:prstGeom prst="roundRect">
+              <a:avLst>
+                <a:gd name="adj" fmla="val 10000"/>
+              </a:avLst>
+            </a:prstGeom>
+            <a:solidFill>
+              <a:srgbClr val="E3EDFB"/>
+            </a:solidFill>
+            <a:ln w="15875">
+              <a:solidFill>
+                <a:srgbClr val="0B57C2"/>
+              </a:solidFill>
+            </a:ln>
+            <a:effectLst/>
+          </p:spPr>
+          <p:style>
+            <a:lnRef idx="1">
+              <a:schemeClr val="accent1"/>
+            </a:lnRef>
+            <a:fillRef idx="3">
+              <a:schemeClr val="accent1"/>
+            </a:fillRef>
+            <a:effectRef idx="2">
+              <a:schemeClr val="accent1"/>
+            </a:effectRef>
+            <a:fontRef idx="minor">
+              <a:schemeClr val="lt1"/>
+            </a:fontRef>
+          </p:style>
+          <p:txBody>
+            <a:bodyPr rtlCol="0" anchor="ctr"/>
+            <a:lstStyle/>
+            <a:p>
+              <a:endParaRPr/>
+            </a:p>
+          </p:txBody>
+        </p:sp>
+        <p:sp>
+          <p:nvSpPr>
+            <p:cNvPr id="31" name="Oval 30"/>
+            <p:cNvSpPr/>
+            <p:nvPr/>
+          </p:nvSpPr>
+          <p:spPr>
+            <a:xfrm>
+              <a:off x="2267712" y="1591056"/>
+              <a:ext cx="292608" cy="292608"/>
+            </a:xfrm>
+            <a:prstGeom prst="ellipse">
+              <a:avLst/>
+            </a:prstGeom>
+            <a:solidFill>
+              <a:srgbClr val="0B57C2"/>
+            </a:solidFill>
+            <a:ln w="9525">
+              <a:solidFill>
+                <a:srgbClr val="0B57C2"/>
+              </a:solidFill>
+            </a:ln>
+            <a:effectLst/>
+          </p:spPr>
+          <p:style>
+            <a:lnRef idx="1">
+              <a:schemeClr val="accent1"/>
+            </a:lnRef>
+            <a:fillRef idx="3">
+              <a:schemeClr val="accent1"/>
+            </a:fillRef>
+            <a:effectRef idx="2">
+              <a:schemeClr val="accent1"/>
+            </a:effectRef>
+            <a:fontRef idx="minor">
+              <a:schemeClr val="lt1"/>
+            </a:fontRef>
+          </p:style>
+          <p:txBody>
+            <a:bodyPr rtlCol="0" anchor="ctr"/>
+            <a:lstStyle/>
+            <a:p>
+              <a:endParaRPr/>
+            </a:p>
+          </p:txBody>
+        </p:sp>
+        <p:pic>
+          <p:nvPicPr>
+            <p:cNvPr id="32" name="Picture 31" descr="FaPiggyBank_w.png"/>
+            <p:cNvPicPr>
+              <a:picLocks noChangeAspect="1"/>
+            </p:cNvPicPr>
+            <p:nvPr/>
+          </p:nvPicPr>
+          <p:blipFill>
+            <a:blip r:embed="rId6"/>
+            <a:stretch>
+              <a:fillRect/>
+            </a:stretch>
+          </p:blipFill>
+          <p:spPr>
+            <a:xfrm>
+              <a:off x="2337937" y="1661281"/>
+              <a:ext cx="152156" cy="152156"/>
+            </a:xfrm>
+            <a:prstGeom prst="rect">
+              <a:avLst/>
+            </a:prstGeom>
+          </p:spPr>
+        </p:pic>
+        <p:sp>
+          <p:nvSpPr>
+            <p:cNvPr id="33" name="TextBox 32"/>
+            <p:cNvSpPr txBox="1"/>
+            <p:nvPr/>
+          </p:nvSpPr>
+          <p:spPr>
+            <a:xfrm>
+              <a:off x="2615184" y="1591056"/>
+              <a:ext cx="1170432" cy="292608"/>
+            </a:xfrm>
+            <a:prstGeom prst="rect">
+              <a:avLst/>
+            </a:prstGeom>
+            <a:noFill/>
+          </p:spPr>
+          <p:txBody>
+            <a:bodyPr wrap="square" lIns="0" tIns="0" rIns="0" bIns="0" anchor="ctr">
+              <a:spAutoFit/>
+            </a:bodyPr>
+            <a:lstStyle/>
+            <a:p>
+              <a:pPr algn="l"/>
+              <a:r>
+                <a:rPr sz="850" b="1" dirty="0">
+                  <a:solidFill>
+                    <a:srgbClr val="0A0A0A"/>
+                  </a:solidFill>
+                  <a:latin typeface="Arial"/>
+                </a:rPr>
+                <a:t>Natural Resource Fund</a:t>
+              </a:r>
+            </a:p>
+          </p:txBody>
+        </p:sp>
+        <p:sp>
+          <p:nvSpPr>
+            <p:cNvPr id="34" name="TextBox 33"/>
+            <p:cNvSpPr txBox="1"/>
+            <p:nvPr/>
+          </p:nvSpPr>
+          <p:spPr>
+            <a:xfrm>
+              <a:off x="2267712" y="1929384"/>
+              <a:ext cx="1499616" cy="502920"/>
+            </a:xfrm>
+            <a:prstGeom prst="rect">
+              <a:avLst/>
+            </a:prstGeom>
+            <a:noFill/>
+          </p:spPr>
+          <p:txBody>
+            <a:bodyPr wrap="square" lIns="0" tIns="0" rIns="0" bIns="0" anchor="t">
+              <a:spAutoFit/>
+            </a:bodyPr>
+            <a:lstStyle/>
+            <a:p>
+              <a:pPr algn="l"/>
+              <a:r>
+                <a:rPr sz="680" b="0">
+                  <a:solidFill>
+                    <a:srgbClr val="0A0A0A"/>
+                  </a:solidFill>
+                  <a:latin typeface="Arial"/>
+                </a:rPr>
+                <a:t>Cadangan minerba milik negara jadi aset dasar; valuasi min. Rp10.000 T; manfaat fiskal Rp1.000 T dalam 3 tahun</a:t>
+              </a:r>
+            </a:p>
+          </p:txBody>
+        </p:sp>
+      </p:grpSp>
+      <p:sp>
+        <p:nvSpPr>
+          <p:cNvPr id="35" name="Rounded Rectangle 34"/>
           <p:cNvSpPr/>
           <p:nvPr/>
         </p:nvSpPr>
         <p:spPr>
           <a:xfrm>
-            <a:off x="2194560" y="1517904"/>
-            <a:ext cx="1645920" cy="932688"/>
+            <a:off x="4160520" y="1517904"/>
+            <a:ext cx="1783080" cy="812800"/>
           </a:xfrm>
           <a:prstGeom prst="roundRect">
             <a:avLst>
@@ -8869,9 +9279,9 @@
             </a:avLst>
           </a:prstGeom>
           <a:solidFill>
-            <a:srgbClr val="E3EDFB"/>
+            <a:srgbClr val="FFFFFF"/>
           </a:solidFill>
-          <a:ln w="15875">
+          <a:ln w="12700">
             <a:solidFill>
               <a:srgbClr val="0B57C2"/>
             </a:solidFill>
@@ -8895,18 +9305,20 @@
         <p:txBody>
           <a:bodyPr rtlCol="0" anchor="ctr"/>
           <a:lstStyle/>
-          <a:p/>
-        </p:txBody>
-      </p:sp>
-      <p:sp>
-        <p:nvSpPr>
-          <p:cNvPr id="31" name="Oval 30"/>
+          <a:p>
+            <a:endParaRPr/>
+          </a:p>
+        </p:txBody>
+      </p:sp>
+      <p:sp>
+        <p:nvSpPr>
+          <p:cNvPr id="36" name="Oval 35"/>
           <p:cNvSpPr/>
           <p:nvPr/>
         </p:nvSpPr>
         <p:spPr>
           <a:xfrm>
-            <a:off x="2267712" y="1591056"/>
+            <a:off x="4233672" y="1591056"/>
             <a:ext cx="292608" cy="292608"/>
           </a:xfrm>
           <a:prstGeom prst="ellipse">
@@ -8939,26 +9351,28 @@
         <p:txBody>
           <a:bodyPr rtlCol="0" anchor="ctr"/>
           <a:lstStyle/>
-          <a:p/>
+          <a:p>
+            <a:endParaRPr/>
+          </a:p>
         </p:txBody>
       </p:sp>
       <p:pic>
         <p:nvPicPr>
-          <p:cNvPr id="32" name="Picture 31" descr="FaPiggyBank_w.png"/>
+          <p:cNvPr id="37" name="Picture 36" descr="FaIndustry_w.png"/>
           <p:cNvPicPr>
             <a:picLocks noChangeAspect="1"/>
           </p:cNvPicPr>
           <p:nvPr/>
         </p:nvPicPr>
         <p:blipFill>
-          <a:blip r:embed="rId6"/>
+          <a:blip r:embed="rId7"/>
           <a:stretch>
             <a:fillRect/>
           </a:stretch>
         </p:blipFill>
         <p:spPr>
           <a:xfrm>
-            <a:off x="2337937" y="1661281"/>
+            <a:off x="4303897" y="1661281"/>
             <a:ext cx="152156" cy="152156"/>
           </a:xfrm>
           <a:prstGeom prst="rect">
@@ -8968,22 +9382,22 @@
       </p:pic>
       <p:sp>
         <p:nvSpPr>
-          <p:cNvPr id="33" name="TextBox 32"/>
-          <p:cNvSpPr txBox="1"/>
-          <p:nvPr/>
-        </p:nvSpPr>
-        <p:spPr>
-          <a:xfrm>
-            <a:off x="2615184" y="1591056"/>
-            <a:ext cx="1170432" cy="292608"/>
-          </a:xfrm>
-          <a:prstGeom prst="rect">
-            <a:avLst/>
-          </a:prstGeom>
-          <a:noFill/>
-        </p:spPr>
-        <p:txBody>
-          <a:bodyPr wrap="square" lIns="0" rIns="0" tIns="0" bIns="0" anchor="ctr">
+          <p:cNvPr id="38" name="TextBox 37"/>
+          <p:cNvSpPr txBox="1"/>
+          <p:nvPr/>
+        </p:nvSpPr>
+        <p:spPr>
+          <a:xfrm>
+            <a:off x="4581144" y="1591056"/>
+            <a:ext cx="1307592" cy="292608"/>
+          </a:xfrm>
+          <a:prstGeom prst="rect">
+            <a:avLst/>
+          </a:prstGeom>
+          <a:noFill/>
+        </p:spPr>
+        <p:txBody>
+          <a:bodyPr wrap="square" lIns="0" tIns="0" rIns="0" bIns="0" anchor="ctr">
             <a:spAutoFit/>
           </a:bodyPr>
           <a:lstStyle/>
@@ -8996,55 +9410,55 @@
                 </a:solidFill>
                 <a:latin typeface="Arial"/>
               </a:rPr>
-              <a:t>Natural Resource Fund</a:t>
-            </a:r>
-          </a:p>
-        </p:txBody>
-      </p:sp>
-      <p:sp>
-        <p:nvSpPr>
-          <p:cNvPr id="34" name="TextBox 33"/>
-          <p:cNvSpPr txBox="1"/>
-          <p:nvPr/>
-        </p:nvSpPr>
-        <p:spPr>
-          <a:xfrm>
-            <a:off x="2267712" y="1929384"/>
-            <a:ext cx="1499616" cy="502920"/>
-          </a:xfrm>
-          <a:prstGeom prst="rect">
-            <a:avLst/>
-          </a:prstGeom>
-          <a:noFill/>
-        </p:spPr>
-        <p:txBody>
-          <a:bodyPr wrap="square" lIns="0" rIns="0" tIns="0" bIns="0" anchor="t">
+              <a:t>Industri hulu &amp; hilirisasi</a:t>
+            </a:r>
+          </a:p>
+        </p:txBody>
+      </p:sp>
+      <p:sp>
+        <p:nvSpPr>
+          <p:cNvPr id="39" name="TextBox 38"/>
+          <p:cNvSpPr txBox="1"/>
+          <p:nvPr/>
+        </p:nvSpPr>
+        <p:spPr>
+          <a:xfrm>
+            <a:off x="4233672" y="1909572"/>
+            <a:ext cx="1636776" cy="381000"/>
+          </a:xfrm>
+          <a:prstGeom prst="rect">
+            <a:avLst/>
+          </a:prstGeom>
+          <a:noFill/>
+        </p:spPr>
+        <p:txBody>
+          <a:bodyPr wrap="square" lIns="0" tIns="0" rIns="0" bIns="0" anchor="t">
             <a:spAutoFit/>
           </a:bodyPr>
           <a:lstStyle/>
           <a:p>
             <a:pPr algn="l"/>
             <a:r>
-              <a:rPr sz="680" b="0">
+              <a:rPr sz="700" b="0">
                 <a:solidFill>
                   <a:srgbClr val="0A0A0A"/>
                 </a:solidFill>
                 <a:latin typeface="Arial"/>
               </a:rPr>
-              <a:t>Cadangan minerba milik negara jadi aset dasar; valuasi min. Rp10.000 T; manfaat fiskal Rp1.000 T dalam 3 tahun</a:t>
-            </a:r>
-          </a:p>
-        </p:txBody>
-      </p:sp>
-      <p:sp>
-        <p:nvSpPr>
-          <p:cNvPr id="35" name="Rounded Rectangle 34"/>
+              <a:t>Nikel HPAL, bauksit–alumina, tembaga, material baterai</a:t>
+            </a:r>
+          </a:p>
+        </p:txBody>
+      </p:sp>
+      <p:sp>
+        <p:nvSpPr>
+          <p:cNvPr id="40" name="Rounded Rectangle 39"/>
           <p:cNvSpPr/>
           <p:nvPr/>
         </p:nvSpPr>
         <p:spPr>
           <a:xfrm>
-            <a:off x="4160520" y="1517904"/>
+            <a:off x="4160520" y="2534412"/>
             <a:ext cx="1783080" cy="812800"/>
           </a:xfrm>
           <a:prstGeom prst="roundRect">
@@ -9079,18 +9493,20 @@
         <p:txBody>
           <a:bodyPr rtlCol="0" anchor="ctr"/>
           <a:lstStyle/>
-          <a:p/>
-        </p:txBody>
-      </p:sp>
-      <p:sp>
-        <p:nvSpPr>
-          <p:cNvPr id="36" name="Oval 35"/>
+          <a:p>
+            <a:endParaRPr/>
+          </a:p>
+        </p:txBody>
+      </p:sp>
+      <p:sp>
+        <p:nvSpPr>
+          <p:cNvPr id="41" name="Oval 40"/>
           <p:cNvSpPr/>
           <p:nvPr/>
         </p:nvSpPr>
         <p:spPr>
           <a:xfrm>
-            <a:off x="4233672" y="1591056"/>
+            <a:off x="4233672" y="2607564"/>
             <a:ext cx="292608" cy="292608"/>
           </a:xfrm>
           <a:prstGeom prst="ellipse">
@@ -9123,26 +9539,28 @@
         <p:txBody>
           <a:bodyPr rtlCol="0" anchor="ctr"/>
           <a:lstStyle/>
-          <a:p/>
+          <a:p>
+            <a:endParaRPr/>
+          </a:p>
         </p:txBody>
       </p:sp>
       <p:pic>
         <p:nvPicPr>
-          <p:cNvPr id="37" name="Picture 36" descr="FaIndustry_w.png"/>
+          <p:cNvPr id="42" name="Picture 41" descr="FaHardHat_w.png"/>
           <p:cNvPicPr>
             <a:picLocks noChangeAspect="1"/>
           </p:cNvPicPr>
           <p:nvPr/>
         </p:nvPicPr>
         <p:blipFill>
-          <a:blip r:embed="rId7"/>
+          <a:blip r:embed="rId8"/>
           <a:stretch>
             <a:fillRect/>
           </a:stretch>
         </p:blipFill>
         <p:spPr>
           <a:xfrm>
-            <a:off x="4303897" y="1661281"/>
+            <a:off x="4303897" y="2677789"/>
             <a:ext cx="152156" cy="152156"/>
           </a:xfrm>
           <a:prstGeom prst="rect">
@@ -9152,13 +9570,13 @@
       </p:pic>
       <p:sp>
         <p:nvSpPr>
-          <p:cNvPr id="38" name="TextBox 37"/>
-          <p:cNvSpPr txBox="1"/>
-          <p:nvPr/>
-        </p:nvSpPr>
-        <p:spPr>
-          <a:xfrm>
-            <a:off x="4581144" y="1591056"/>
+          <p:cNvPr id="43" name="TextBox 42"/>
+          <p:cNvSpPr txBox="1"/>
+          <p:nvPr/>
+        </p:nvSpPr>
+        <p:spPr>
+          <a:xfrm>
+            <a:off x="4581144" y="2607564"/>
             <a:ext cx="1307592" cy="292608"/>
           </a:xfrm>
           <a:prstGeom prst="rect">
@@ -9167,7 +9585,7 @@
           <a:noFill/>
         </p:spPr>
         <p:txBody>
-          <a:bodyPr wrap="square" lIns="0" rIns="0" tIns="0" bIns="0" anchor="ctr">
+          <a:bodyPr wrap="square" lIns="0" tIns="0" rIns="0" bIns="0" anchor="ctr">
             <a:spAutoFit/>
           </a:bodyPr>
           <a:lstStyle/>
@@ -9180,20 +9598,20 @@
                 </a:solidFill>
                 <a:latin typeface="Arial"/>
               </a:rPr>
-              <a:t>Industri hulu &amp; hilirisasi</a:t>
-            </a:r>
-          </a:p>
-        </p:txBody>
-      </p:sp>
-      <p:sp>
-        <p:nvSpPr>
-          <p:cNvPr id="39" name="TextBox 38"/>
-          <p:cNvSpPr txBox="1"/>
-          <p:nvPr/>
-        </p:nvSpPr>
-        <p:spPr>
-          <a:xfrm>
-            <a:off x="4233672" y="1909572"/>
+              <a:t>Proyek infrastruktur</a:t>
+            </a:r>
+          </a:p>
+        </p:txBody>
+      </p:sp>
+      <p:sp>
+        <p:nvSpPr>
+          <p:cNvPr id="44" name="TextBox 43"/>
+          <p:cNvSpPr txBox="1"/>
+          <p:nvPr/>
+        </p:nvSpPr>
+        <p:spPr>
+          <a:xfrm>
+            <a:off x="4233672" y="2926080"/>
             <a:ext cx="1636776" cy="381000"/>
           </a:xfrm>
           <a:prstGeom prst="rect">
@@ -9202,7 +9620,7 @@
           <a:noFill/>
         </p:spPr>
         <p:txBody>
-          <a:bodyPr wrap="square" lIns="0" rIns="0" tIns="0" bIns="0" anchor="t">
+          <a:bodyPr wrap="square" lIns="0" tIns="0" rIns="0" bIns="0" anchor="t">
             <a:spAutoFit/>
           </a:bodyPr>
           <a:lstStyle/>
@@ -9215,20 +9633,20 @@
                 </a:solidFill>
                 <a:latin typeface="Arial"/>
               </a:rPr>
-              <a:t>Nikel HPAL, bauksit–alumina, tembaga, material baterai</a:t>
-            </a:r>
-          </a:p>
-        </p:txBody>
-      </p:sp>
-      <p:sp>
-        <p:nvSpPr>
-          <p:cNvPr id="40" name="Rounded Rectangle 39"/>
+              <a:t>Giant Sea Wall, energi, WtE, kota cerdas, perumahan, air</a:t>
+            </a:r>
+          </a:p>
+        </p:txBody>
+      </p:sp>
+      <p:sp>
+        <p:nvSpPr>
+          <p:cNvPr id="45" name="Rounded Rectangle 44"/>
           <p:cNvSpPr/>
           <p:nvPr/>
         </p:nvSpPr>
         <p:spPr>
           <a:xfrm>
-            <a:off x="4160520" y="2534412"/>
+            <a:off x="4160520" y="3550920"/>
             <a:ext cx="1783080" cy="812800"/>
           </a:xfrm>
           <a:prstGeom prst="roundRect">
@@ -9263,18 +9681,20 @@
         <p:txBody>
           <a:bodyPr rtlCol="0" anchor="ctr"/>
           <a:lstStyle/>
-          <a:p/>
-        </p:txBody>
-      </p:sp>
-      <p:sp>
-        <p:nvSpPr>
-          <p:cNvPr id="41" name="Oval 40"/>
+          <a:p>
+            <a:endParaRPr/>
+          </a:p>
+        </p:txBody>
+      </p:sp>
+      <p:sp>
+        <p:nvSpPr>
+          <p:cNvPr id="46" name="Oval 45"/>
           <p:cNvSpPr/>
           <p:nvPr/>
         </p:nvSpPr>
         <p:spPr>
           <a:xfrm>
-            <a:off x="4233672" y="2607564"/>
+            <a:off x="4233672" y="3624072"/>
             <a:ext cx="292608" cy="292608"/>
           </a:xfrm>
           <a:prstGeom prst="ellipse">
@@ -9307,26 +9727,28 @@
         <p:txBody>
           <a:bodyPr rtlCol="0" anchor="ctr"/>
           <a:lstStyle/>
-          <a:p/>
+          <a:p>
+            <a:endParaRPr/>
+          </a:p>
         </p:txBody>
       </p:sp>
       <p:pic>
         <p:nvPicPr>
-          <p:cNvPr id="42" name="Picture 41" descr="FaHardHat_w.png"/>
+          <p:cNvPr id="47" name="Picture 46" descr="FaShip_w.png"/>
           <p:cNvPicPr>
             <a:picLocks noChangeAspect="1"/>
           </p:cNvPicPr>
           <p:nvPr/>
         </p:nvPicPr>
         <p:blipFill>
-          <a:blip r:embed="rId8"/>
+          <a:blip r:embed="rId9"/>
           <a:stretch>
             <a:fillRect/>
           </a:stretch>
         </p:blipFill>
         <p:spPr>
           <a:xfrm>
-            <a:off x="4303897" y="2677789"/>
+            <a:off x="4303897" y="3694297"/>
             <a:ext cx="152156" cy="152156"/>
           </a:xfrm>
           <a:prstGeom prst="rect">
@@ -9336,13 +9758,13 @@
       </p:pic>
       <p:sp>
         <p:nvSpPr>
-          <p:cNvPr id="43" name="TextBox 42"/>
-          <p:cNvSpPr txBox="1"/>
-          <p:nvPr/>
-        </p:nvSpPr>
-        <p:spPr>
-          <a:xfrm>
-            <a:off x="4581144" y="2607564"/>
+          <p:cNvPr id="48" name="TextBox 47"/>
+          <p:cNvSpPr txBox="1"/>
+          <p:nvPr/>
+        </p:nvSpPr>
+        <p:spPr>
+          <a:xfrm>
+            <a:off x="4581144" y="3624072"/>
             <a:ext cx="1307592" cy="292608"/>
           </a:xfrm>
           <a:prstGeom prst="rect">
@@ -9351,7 +9773,7 @@
           <a:noFill/>
         </p:spPr>
         <p:txBody>
-          <a:bodyPr wrap="square" lIns="0" rIns="0" tIns="0" bIns="0" anchor="ctr">
+          <a:bodyPr wrap="square" lIns="0" tIns="0" rIns="0" bIns="0" anchor="ctr">
             <a:spAutoFit/>
           </a:bodyPr>
           <a:lstStyle/>
@@ -9364,20 +9786,20 @@
                 </a:solidFill>
                 <a:latin typeface="Arial"/>
               </a:rPr>
-              <a:t>Proyek infrastruktur</a:t>
-            </a:r>
-          </a:p>
-        </p:txBody>
-      </p:sp>
-      <p:sp>
-        <p:nvSpPr>
-          <p:cNvPr id="44" name="TextBox 43"/>
-          <p:cNvSpPr txBox="1"/>
-          <p:nvPr/>
-        </p:nvSpPr>
-        <p:spPr>
-          <a:xfrm>
-            <a:off x="4233672" y="2926080"/>
+              <a:t>Proyek pertahanan</a:t>
+            </a:r>
+          </a:p>
+        </p:txBody>
+      </p:sp>
+      <p:sp>
+        <p:nvSpPr>
+          <p:cNvPr id="49" name="TextBox 48"/>
+          <p:cNvSpPr txBox="1"/>
+          <p:nvPr/>
+        </p:nvSpPr>
+        <p:spPr>
+          <a:xfrm>
+            <a:off x="4233672" y="3942588"/>
             <a:ext cx="1636776" cy="381000"/>
           </a:xfrm>
           <a:prstGeom prst="rect">
@@ -9386,7 +9808,7 @@
           <a:noFill/>
         </p:spPr>
         <p:txBody>
-          <a:bodyPr wrap="square" lIns="0" rIns="0" tIns="0" bIns="0" anchor="t">
+          <a:bodyPr wrap="square" lIns="0" tIns="0" rIns="0" bIns="0" anchor="t">
             <a:spAutoFit/>
           </a:bodyPr>
           <a:lstStyle/>
@@ -9399,20 +9821,20 @@
                 </a:solidFill>
                 <a:latin typeface="Arial"/>
               </a:rPr>
-              <a:t>Giant Sea Wall, energi, WtE, kota cerdas, perumahan, air</a:t>
-            </a:r>
-          </a:p>
-        </p:txBody>
-      </p:sp>
-      <p:sp>
-        <p:nvSpPr>
-          <p:cNvPr id="45" name="Rounded Rectangle 44"/>
+              <a:t>Kapal selam, fregat, LPD, MRO, DEFEND ID</a:t>
+            </a:r>
+          </a:p>
+        </p:txBody>
+      </p:sp>
+      <p:sp>
+        <p:nvSpPr>
+          <p:cNvPr id="50" name="Rounded Rectangle 49"/>
           <p:cNvSpPr/>
           <p:nvPr/>
         </p:nvSpPr>
         <p:spPr>
           <a:xfrm>
-            <a:off x="4160520" y="3550920"/>
+            <a:off x="4160520" y="4567428"/>
             <a:ext cx="1783080" cy="812800"/>
           </a:xfrm>
           <a:prstGeom prst="roundRect">
@@ -9447,18 +9869,20 @@
         <p:txBody>
           <a:bodyPr rtlCol="0" anchor="ctr"/>
           <a:lstStyle/>
-          <a:p/>
-        </p:txBody>
-      </p:sp>
-      <p:sp>
-        <p:nvSpPr>
-          <p:cNvPr id="46" name="Oval 45"/>
+          <a:p>
+            <a:endParaRPr/>
+          </a:p>
+        </p:txBody>
+      </p:sp>
+      <p:sp>
+        <p:nvSpPr>
+          <p:cNvPr id="51" name="Oval 50"/>
           <p:cNvSpPr/>
           <p:nvPr/>
         </p:nvSpPr>
         <p:spPr>
           <a:xfrm>
-            <a:off x="4233672" y="3624072"/>
+            <a:off x="4233672" y="4640580"/>
             <a:ext cx="292608" cy="292608"/>
           </a:xfrm>
           <a:prstGeom prst="ellipse">
@@ -9491,26 +9915,28 @@
         <p:txBody>
           <a:bodyPr rtlCol="0" anchor="ctr"/>
           <a:lstStyle/>
-          <a:p/>
+          <a:p>
+            <a:endParaRPr/>
+          </a:p>
         </p:txBody>
       </p:sp>
       <p:pic>
         <p:nvPicPr>
-          <p:cNvPr id="47" name="Picture 46" descr="FaShip_w.png"/>
+          <p:cNvPr id="52" name="Picture 51" descr="FaCogs_w.png"/>
           <p:cNvPicPr>
             <a:picLocks noChangeAspect="1"/>
           </p:cNvPicPr>
           <p:nvPr/>
         </p:nvPicPr>
         <p:blipFill>
-          <a:blip r:embed="rId9"/>
+          <a:blip r:embed="rId10"/>
           <a:stretch>
             <a:fillRect/>
           </a:stretch>
         </p:blipFill>
         <p:spPr>
           <a:xfrm>
-            <a:off x="4303897" y="3694297"/>
+            <a:off x="4303897" y="4710805"/>
             <a:ext cx="152156" cy="152156"/>
           </a:xfrm>
           <a:prstGeom prst="rect">
@@ -9520,13 +9946,13 @@
       </p:pic>
       <p:sp>
         <p:nvSpPr>
-          <p:cNvPr id="48" name="TextBox 47"/>
-          <p:cNvSpPr txBox="1"/>
-          <p:nvPr/>
-        </p:nvSpPr>
-        <p:spPr>
-          <a:xfrm>
-            <a:off x="4581144" y="3624072"/>
+          <p:cNvPr id="53" name="TextBox 52"/>
+          <p:cNvSpPr txBox="1"/>
+          <p:nvPr/>
+        </p:nvSpPr>
+        <p:spPr>
+          <a:xfrm>
+            <a:off x="4581144" y="4640580"/>
             <a:ext cx="1307592" cy="292608"/>
           </a:xfrm>
           <a:prstGeom prst="rect">
@@ -9535,7 +9961,7 @@
           <a:noFill/>
         </p:spPr>
         <p:txBody>
-          <a:bodyPr wrap="square" lIns="0" rIns="0" tIns="0" bIns="0" anchor="ctr">
+          <a:bodyPr wrap="square" lIns="0" tIns="0" rIns="0" bIns="0" anchor="ctr">
             <a:spAutoFit/>
           </a:bodyPr>
           <a:lstStyle/>
@@ -9548,20 +9974,20 @@
                 </a:solidFill>
                 <a:latin typeface="Arial"/>
               </a:rPr>
-              <a:t>Proyek pertahanan</a:t>
-            </a:r>
-          </a:p>
-        </p:txBody>
-      </p:sp>
-      <p:sp>
-        <p:nvSpPr>
-          <p:cNvPr id="49" name="TextBox 48"/>
-          <p:cNvSpPr txBox="1"/>
-          <p:nvPr/>
-        </p:nvSpPr>
-        <p:spPr>
-          <a:xfrm>
-            <a:off x="4233672" y="3942588"/>
+              <a:t>Proyek AI &amp; digital</a:t>
+            </a:r>
+          </a:p>
+        </p:txBody>
+      </p:sp>
+      <p:sp>
+        <p:nvSpPr>
+          <p:cNvPr id="54" name="TextBox 53"/>
+          <p:cNvSpPr txBox="1"/>
+          <p:nvPr/>
+        </p:nvSpPr>
+        <p:spPr>
+          <a:xfrm>
+            <a:off x="4233672" y="4959096"/>
             <a:ext cx="1636776" cy="381000"/>
           </a:xfrm>
           <a:prstGeom prst="rect">
@@ -9570,7 +9996,7 @@
           <a:noFill/>
         </p:spPr>
         <p:txBody>
-          <a:bodyPr wrap="square" lIns="0" rIns="0" tIns="0" bIns="0" anchor="t">
+          <a:bodyPr wrap="square" lIns="0" tIns="0" rIns="0" bIns="0" anchor="t">
             <a:spAutoFit/>
           </a:bodyPr>
           <a:lstStyle/>
@@ -9583,33 +10009,33 @@
                 </a:solidFill>
                 <a:latin typeface="Arial"/>
               </a:rPr>
-              <a:t>Kapal selam, fregat, LPD, MRO, DEFEND ID</a:t>
-            </a:r>
-          </a:p>
-        </p:txBody>
-      </p:sp>
-      <p:sp>
-        <p:nvSpPr>
-          <p:cNvPr id="50" name="Rounded Rectangle 49"/>
+              <a:t>6 agen: risiko, bid/no-bid, biaya, piutang, jadwal, pengadaan; KDKMP</a:t>
+            </a:r>
+          </a:p>
+        </p:txBody>
+      </p:sp>
+      <p:sp>
+        <p:nvSpPr>
+          <p:cNvPr id="55" name="Rounded Rectangle 54"/>
           <p:cNvSpPr/>
           <p:nvPr/>
         </p:nvSpPr>
         <p:spPr>
           <a:xfrm>
-            <a:off x="4160520" y="4567428"/>
-            <a:ext cx="1783080" cy="812800"/>
+            <a:off x="6263640" y="1517904"/>
+            <a:ext cx="502920" cy="2844800"/>
           </a:xfrm>
           <a:prstGeom prst="roundRect">
             <a:avLst>
-              <a:gd name="adj" fmla="val 10000"/>
+              <a:gd name="adj" fmla="val 15000"/>
             </a:avLst>
           </a:prstGeom>
           <a:solidFill>
-            <a:srgbClr val="FFFFFF"/>
+            <a:srgbClr val="0A0A0A"/>
           </a:solidFill>
-          <a:ln w="12700">
+          <a:ln w="9525">
             <a:solidFill>
-              <a:srgbClr val="0B57C2"/>
+              <a:srgbClr val="0A0A0A"/>
             </a:solidFill>
           </a:ln>
           <a:effectLst/>
@@ -9631,22 +10057,73 @@
         <p:txBody>
           <a:bodyPr rtlCol="0" anchor="ctr"/>
           <a:lstStyle/>
-          <a:p/>
-        </p:txBody>
-      </p:sp>
-      <p:sp>
-        <p:nvSpPr>
-          <p:cNvPr id="51" name="Oval 50"/>
+          <a:p>
+            <a:endParaRPr/>
+          </a:p>
+        </p:txBody>
+      </p:sp>
+      <p:sp>
+        <p:nvSpPr>
+          <p:cNvPr id="56" name="TextBox 55"/>
+          <p:cNvSpPr txBox="1"/>
+          <p:nvPr/>
+        </p:nvSpPr>
+        <p:spPr>
+          <a:xfrm>
+            <a:off x="6263640" y="1517904"/>
+            <a:ext cx="502920" cy="2844800"/>
+          </a:xfrm>
+          <a:prstGeom prst="rect">
+            <a:avLst/>
+          </a:prstGeom>
+          <a:noFill/>
+        </p:spPr>
+        <p:txBody>
+          <a:bodyPr vert="vert270" wrap="square" lIns="0" tIns="0" rIns="0" bIns="0" anchor="ctr">
+            <a:spAutoFit/>
+          </a:bodyPr>
+          <a:lstStyle/>
+          <a:p>
+            <a:pPr algn="ctr"/>
+            <a:r>
+              <a:rPr sz="1100" b="1">
+                <a:solidFill>
+                  <a:srgbClr val="FFFFFF"/>
+                </a:solidFill>
+                <a:latin typeface="Arial"/>
+              </a:rPr>
+              <a:t>DOCK-UP</a:t>
+            </a:r>
+          </a:p>
+          <a:p>
+            <a:pPr algn="ctr"/>
+            <a:r>
+              <a:rPr sz="750" b="0">
+                <a:solidFill>
+                  <a:srgbClr val="9DBCEB"/>
+                </a:solidFill>
+                <a:latin typeface="Arial"/>
+              </a:rPr>
+              <a:t>Develop · Off-taker · Certification · Upgrading</a:t>
+            </a:r>
+          </a:p>
+        </p:txBody>
+      </p:sp>
+      <p:sp>
+        <p:nvSpPr>
+          <p:cNvPr id="57" name="Rounded Rectangle 56"/>
           <p:cNvSpPr/>
           <p:nvPr/>
         </p:nvSpPr>
         <p:spPr>
           <a:xfrm>
-            <a:off x="4233672" y="4640580"/>
-            <a:ext cx="292608" cy="292608"/>
-          </a:xfrm>
-          <a:prstGeom prst="ellipse">
-            <a:avLst/>
+            <a:off x="7086600" y="1517904"/>
+            <a:ext cx="502920" cy="3860800"/>
+          </a:xfrm>
+          <a:prstGeom prst="roundRect">
+            <a:avLst>
+              <a:gd name="adj" fmla="val 15000"/>
+            </a:avLst>
           </a:prstGeom>
           <a:solidFill>
             <a:srgbClr val="0B57C2"/>
@@ -9675,125 +10152,80 @@
         <p:txBody>
           <a:bodyPr rtlCol="0" anchor="ctr"/>
           <a:lstStyle/>
-          <a:p/>
-        </p:txBody>
-      </p:sp>
-      <p:pic>
-        <p:nvPicPr>
-          <p:cNvPr id="52" name="Picture 51" descr="FaCogs_w.png"/>
-          <p:cNvPicPr>
-            <a:picLocks noChangeAspect="1"/>
-          </p:cNvPicPr>
-          <p:nvPr/>
-        </p:nvPicPr>
-        <p:blipFill>
-          <a:blip r:embed="rId10"/>
-          <a:stretch>
-            <a:fillRect/>
-          </a:stretch>
-        </p:blipFill>
-        <p:spPr>
-          <a:xfrm>
-            <a:off x="4303897" y="4710805"/>
-            <a:ext cx="152156" cy="152156"/>
-          </a:xfrm>
-          <a:prstGeom prst="rect">
-            <a:avLst/>
-          </a:prstGeom>
-        </p:spPr>
-      </p:pic>
-      <p:sp>
-        <p:nvSpPr>
-          <p:cNvPr id="53" name="TextBox 52"/>
-          <p:cNvSpPr txBox="1"/>
-          <p:nvPr/>
-        </p:nvSpPr>
-        <p:spPr>
-          <a:xfrm>
-            <a:off x="4581144" y="4640580"/>
-            <a:ext cx="1307592" cy="292608"/>
-          </a:xfrm>
-          <a:prstGeom prst="rect">
-            <a:avLst/>
-          </a:prstGeom>
-          <a:noFill/>
-        </p:spPr>
-        <p:txBody>
-          <a:bodyPr wrap="square" lIns="0" rIns="0" tIns="0" bIns="0" anchor="ctr">
+          <a:p>
+            <a:endParaRPr/>
+          </a:p>
+        </p:txBody>
+      </p:sp>
+      <p:sp>
+        <p:nvSpPr>
+          <p:cNvPr id="58" name="TextBox 57"/>
+          <p:cNvSpPr txBox="1"/>
+          <p:nvPr/>
+        </p:nvSpPr>
+        <p:spPr>
+          <a:xfrm>
+            <a:off x="7086600" y="1517904"/>
+            <a:ext cx="502920" cy="3860800"/>
+          </a:xfrm>
+          <a:prstGeom prst="rect">
+            <a:avLst/>
+          </a:prstGeom>
+          <a:noFill/>
+        </p:spPr>
+        <p:txBody>
+          <a:bodyPr vert="vert270" wrap="square" lIns="0" tIns="0" rIns="0" bIns="0" anchor="ctr">
             <a:spAutoFit/>
           </a:bodyPr>
           <a:lstStyle/>
           <a:p>
-            <a:pPr algn="l"/>
-            <a:r>
-              <a:rPr sz="850" b="1">
-                <a:solidFill>
-                  <a:srgbClr val="0A0A0A"/>
+            <a:pPr algn="ctr"/>
+            <a:r>
+              <a:rPr sz="1100" b="1">
+                <a:solidFill>
+                  <a:srgbClr val="FFFFFF"/>
                 </a:solidFill>
                 <a:latin typeface="Arial"/>
               </a:rPr>
-              <a:t>Proyek AI &amp; digital</a:t>
-            </a:r>
-          </a:p>
-        </p:txBody>
-      </p:sp>
-      <p:sp>
-        <p:nvSpPr>
-          <p:cNvPr id="54" name="TextBox 53"/>
-          <p:cNvSpPr txBox="1"/>
-          <p:nvPr/>
-        </p:nvSpPr>
-        <p:spPr>
-          <a:xfrm>
-            <a:off x="4233672" y="4959096"/>
-            <a:ext cx="1636776" cy="381000"/>
-          </a:xfrm>
-          <a:prstGeom prst="rect">
-            <a:avLst/>
-          </a:prstGeom>
-          <a:noFill/>
-        </p:spPr>
-        <p:txBody>
-          <a:bodyPr wrap="square" lIns="0" rIns="0" tIns="0" bIns="0" anchor="t">
-            <a:spAutoFit/>
-          </a:bodyPr>
-          <a:lstStyle/>
-          <a:p>
-            <a:pPr algn="l"/>
-            <a:r>
-              <a:rPr sz="700" b="0">
-                <a:solidFill>
-                  <a:srgbClr val="0A0A0A"/>
+              <a:t>SISTEM AI MULTI-AGEN</a:t>
+            </a:r>
+          </a:p>
+          <a:p>
+            <a:pPr algn="ctr"/>
+            <a:r>
+              <a:rPr sz="750" b="0">
+                <a:solidFill>
+                  <a:srgbClr val="E3EDFB"/>
                 </a:solidFill>
                 <a:latin typeface="Arial"/>
               </a:rPr>
-              <a:t>6 agen: risiko, bid/no-bid, biaya, piutang, jadwal, pengadaan; KDKMP</a:t>
-            </a:r>
-          </a:p>
-        </p:txBody>
-      </p:sp>
-      <p:sp>
-        <p:nvSpPr>
-          <p:cNvPr id="55" name="Rounded Rectangle 54"/>
+              <a:t>master data tunggal · control tower portofolio</a:t>
+            </a:r>
+          </a:p>
+        </p:txBody>
+      </p:sp>
+      <p:sp>
+        <p:nvSpPr>
+          <p:cNvPr id="59" name="Rounded Rectangle 58"/>
           <p:cNvSpPr/>
           <p:nvPr/>
         </p:nvSpPr>
         <p:spPr>
           <a:xfrm>
-            <a:off x="6263640" y="1517904"/>
-            <a:ext cx="502920" cy="2844800"/>
+            <a:off x="7909560" y="1517904"/>
+            <a:ext cx="2459736" cy="3860800"/>
           </a:xfrm>
           <a:prstGeom prst="roundRect">
             <a:avLst>
-              <a:gd name="adj" fmla="val 15000"/>
+              <a:gd name="adj" fmla="val 4000"/>
             </a:avLst>
           </a:prstGeom>
           <a:solidFill>
-            <a:srgbClr val="0A0A0A"/>
+            <a:srgbClr val="E3EDFB"/>
           </a:solidFill>
           <a:ln w="9525">
             <a:solidFill>
-              <a:srgbClr val="0A0A0A"/>
+              <a:srgbClr val="E3EDFB"/>
             </a:solidFill>
           </a:ln>
           <a:effectLst/>
@@ -9815,71 +10247,24 @@
         <p:txBody>
           <a:bodyPr rtlCol="0" anchor="ctr"/>
           <a:lstStyle/>
-          <a:p/>
-        </p:txBody>
-      </p:sp>
-      <p:sp>
-        <p:nvSpPr>
-          <p:cNvPr id="56" name="TextBox 55"/>
-          <p:cNvSpPr txBox="1"/>
-          <p:nvPr/>
-        </p:nvSpPr>
-        <p:spPr>
-          <a:xfrm>
-            <a:off x="6263640" y="1517904"/>
-            <a:ext cx="502920" cy="2844800"/>
-          </a:xfrm>
-          <a:prstGeom prst="rect">
-            <a:avLst/>
-          </a:prstGeom>
-          <a:noFill/>
-        </p:spPr>
-        <p:txBody>
-          <a:bodyPr wrap="square" lIns="0" rIns="0" tIns="0" bIns="0" anchor="ctr" vert="vert270">
-            <a:spAutoFit/>
-          </a:bodyPr>
-          <a:lstStyle/>
-          <a:p>
-            <a:pPr algn="ctr"/>
-            <a:r>
-              <a:rPr sz="1100" b="1">
-                <a:solidFill>
-                  <a:srgbClr val="FFFFFF"/>
-                </a:solidFill>
-                <a:latin typeface="Arial"/>
-              </a:rPr>
-              <a:t>DOCK-UP</a:t>
-            </a:r>
-          </a:p>
-          <a:p>
-            <a:pPr algn="ctr"/>
-            <a:r>
-              <a:rPr sz="750" b="0">
-                <a:solidFill>
-                  <a:srgbClr val="9DBCEB"/>
-                </a:solidFill>
-                <a:latin typeface="Arial"/>
-              </a:rPr>
-              <a:t>Develop · Off-taker · Certification · Upgrading</a:t>
-            </a:r>
-          </a:p>
-        </p:txBody>
-      </p:sp>
-      <p:sp>
-        <p:nvSpPr>
-          <p:cNvPr id="57" name="Rounded Rectangle 56"/>
+          <a:p>
+            <a:endParaRPr/>
+          </a:p>
+        </p:txBody>
+      </p:sp>
+      <p:sp>
+        <p:nvSpPr>
+          <p:cNvPr id="60" name="Oval 59"/>
           <p:cNvSpPr/>
           <p:nvPr/>
         </p:nvSpPr>
         <p:spPr>
           <a:xfrm>
-            <a:off x="7086600" y="1517904"/>
-            <a:ext cx="502920" cy="3860800"/>
-          </a:xfrm>
-          <a:prstGeom prst="roundRect">
-            <a:avLst>
-              <a:gd name="adj" fmla="val 15000"/>
-            </a:avLst>
+            <a:off x="8001000" y="1609344"/>
+            <a:ext cx="329184" cy="329184"/>
+          </a:xfrm>
+          <a:prstGeom prst="ellipse">
+            <a:avLst/>
           </a:prstGeom>
           <a:solidFill>
             <a:srgbClr val="0B57C2"/>
@@ -9908,144 +10293,9 @@
         <p:txBody>
           <a:bodyPr rtlCol="0" anchor="ctr"/>
           <a:lstStyle/>
-          <a:p/>
-        </p:txBody>
-      </p:sp>
-      <p:sp>
-        <p:nvSpPr>
-          <p:cNvPr id="58" name="TextBox 57"/>
-          <p:cNvSpPr txBox="1"/>
-          <p:nvPr/>
-        </p:nvSpPr>
-        <p:spPr>
-          <a:xfrm>
-            <a:off x="7086600" y="1517904"/>
-            <a:ext cx="502920" cy="3860800"/>
-          </a:xfrm>
-          <a:prstGeom prst="rect">
-            <a:avLst/>
-          </a:prstGeom>
-          <a:noFill/>
-        </p:spPr>
-        <p:txBody>
-          <a:bodyPr wrap="square" lIns="0" rIns="0" tIns="0" bIns="0" anchor="ctr" vert="vert270">
-            <a:spAutoFit/>
-          </a:bodyPr>
-          <a:lstStyle/>
-          <a:p>
-            <a:pPr algn="ctr"/>
-            <a:r>
-              <a:rPr sz="1100" b="1">
-                <a:solidFill>
-                  <a:srgbClr val="FFFFFF"/>
-                </a:solidFill>
-                <a:latin typeface="Arial"/>
-              </a:rPr>
-              <a:t>SISTEM AI MULTI-AGEN</a:t>
-            </a:r>
-          </a:p>
-          <a:p>
-            <a:pPr algn="ctr"/>
-            <a:r>
-              <a:rPr sz="750" b="0">
-                <a:solidFill>
-                  <a:srgbClr val="E3EDFB"/>
-                </a:solidFill>
-                <a:latin typeface="Arial"/>
-              </a:rPr>
-              <a:t>master data tunggal · control tower portofolio</a:t>
-            </a:r>
-          </a:p>
-        </p:txBody>
-      </p:sp>
-      <p:sp>
-        <p:nvSpPr>
-          <p:cNvPr id="59" name="Rounded Rectangle 58"/>
-          <p:cNvSpPr/>
-          <p:nvPr/>
-        </p:nvSpPr>
-        <p:spPr>
-          <a:xfrm>
-            <a:off x="7909560" y="1517904"/>
-            <a:ext cx="2459736" cy="3860800"/>
-          </a:xfrm>
-          <a:prstGeom prst="roundRect">
-            <a:avLst>
-              <a:gd name="adj" fmla="val 4000"/>
-            </a:avLst>
-          </a:prstGeom>
-          <a:solidFill>
-            <a:srgbClr val="E3EDFB"/>
-          </a:solidFill>
-          <a:ln w="9525">
-            <a:solidFill>
-              <a:srgbClr val="E3EDFB"/>
-            </a:solidFill>
-          </a:ln>
-          <a:effectLst/>
-        </p:spPr>
-        <p:style>
-          <a:lnRef idx="1">
-            <a:schemeClr val="accent1"/>
-          </a:lnRef>
-          <a:fillRef idx="3">
-            <a:schemeClr val="accent1"/>
-          </a:fillRef>
-          <a:effectRef idx="2">
-            <a:schemeClr val="accent1"/>
-          </a:effectRef>
-          <a:fontRef idx="minor">
-            <a:schemeClr val="lt1"/>
-          </a:fontRef>
-        </p:style>
-        <p:txBody>
-          <a:bodyPr rtlCol="0" anchor="ctr"/>
-          <a:lstStyle/>
-          <a:p/>
-        </p:txBody>
-      </p:sp>
-      <p:sp>
-        <p:nvSpPr>
-          <p:cNvPr id="60" name="Oval 59"/>
-          <p:cNvSpPr/>
-          <p:nvPr/>
-        </p:nvSpPr>
-        <p:spPr>
-          <a:xfrm>
-            <a:off x="8001000" y="1609344"/>
-            <a:ext cx="329184" cy="329184"/>
-          </a:xfrm>
-          <a:prstGeom prst="ellipse">
-            <a:avLst/>
-          </a:prstGeom>
-          <a:solidFill>
-            <a:srgbClr val="0B57C2"/>
-          </a:solidFill>
-          <a:ln w="9525">
-            <a:solidFill>
-              <a:srgbClr val="0B57C2"/>
-            </a:solidFill>
-          </a:ln>
-          <a:effectLst/>
-        </p:spPr>
-        <p:style>
-          <a:lnRef idx="1">
-            <a:schemeClr val="accent1"/>
-          </a:lnRef>
-          <a:fillRef idx="3">
-            <a:schemeClr val="accent1"/>
-          </a:fillRef>
-          <a:effectRef idx="2">
-            <a:schemeClr val="accent1"/>
-          </a:effectRef>
-          <a:fontRef idx="minor">
-            <a:schemeClr val="lt1"/>
-          </a:fontRef>
-        </p:style>
-        <p:txBody>
-          <a:bodyPr rtlCol="0" anchor="ctr"/>
-          <a:lstStyle/>
-          <a:p/>
+          <a:p>
+            <a:endParaRPr/>
+          </a:p>
         </p:txBody>
       </p:sp>
       <p:pic>
@@ -10089,7 +10339,7 @@
           <a:noFill/>
         </p:spPr>
         <p:txBody>
-          <a:bodyPr wrap="square" lIns="0" rIns="0" tIns="0" bIns="0" anchor="ctr">
+          <a:bodyPr wrap="square" lIns="0" tIns="0" rIns="0" bIns="0" anchor="ctr">
             <a:spAutoFit/>
           </a:bodyPr>
           <a:lstStyle/>
@@ -10124,7 +10374,7 @@
           <a:noFill/>
         </p:spPr>
         <p:txBody>
-          <a:bodyPr wrap="square" lIns="0" rIns="0" tIns="0" bIns="0" anchor="t">
+          <a:bodyPr wrap="square" lIns="0" tIns="0" rIns="0" bIns="0" anchor="t">
             <a:spAutoFit/>
           </a:bodyPr>
           <a:lstStyle/>
@@ -10150,29 +10400,47 @@
         </p:nvSpPr>
         <p:spPr>
           <a:xfrm>
-            <a:off x="8037576" y="2171700"/>
-            <a:ext cx="2203704" cy="237744"/>
-          </a:xfrm>
-          <a:prstGeom prst="rect">
-            <a:avLst/>
-          </a:prstGeom>
-          <a:noFill/>
-        </p:spPr>
-        <p:txBody>
-          <a:bodyPr wrap="square" lIns="0" rIns="0" tIns="0" bIns="0" anchor="ctr">
+            <a:off x="8037576" y="2198239"/>
+            <a:ext cx="2203704" cy="184666"/>
+          </a:xfrm>
+          <a:prstGeom prst="rect">
+            <a:avLst/>
+          </a:prstGeom>
+          <a:noFill/>
+        </p:spPr>
+        <p:txBody>
+          <a:bodyPr wrap="square" lIns="0" tIns="0" rIns="0" bIns="0" anchor="ctr">
             <a:spAutoFit/>
           </a:bodyPr>
           <a:lstStyle/>
           <a:p>
             <a:pPr algn="l"/>
             <a:r>
-              <a:rPr sz="1200" b="1">
+              <a:rPr sz="1200" b="1" dirty="0">
                 <a:solidFill>
                   <a:srgbClr val="0B57C2"/>
                 </a:solidFill>
                 <a:latin typeface="Arial"/>
               </a:rPr>
-              <a:t>+1,55%</a:t>
+              <a:t>+</a:t>
+            </a:r>
+            <a:r>
+              <a:rPr lang="en-US" sz="1200" b="1" dirty="0">
+                <a:solidFill>
+                  <a:srgbClr val="0B57C2"/>
+                </a:solidFill>
+                <a:latin typeface="Arial"/>
+              </a:rPr>
+              <a:t> X,XX</a:t>
+            </a:r>
+            <a:r>
+              <a:rPr sz="1200" b="1" dirty="0">
+                <a:solidFill>
+                  <a:srgbClr val="0B57C2"/>
+                </a:solidFill>
+                <a:latin typeface="Arial"/>
+              </a:rPr>
+              <a:t>%</a:t>
             </a:r>
           </a:p>
         </p:txBody>
@@ -10194,7 +10462,7 @@
           <a:noFill/>
         </p:spPr>
         <p:txBody>
-          <a:bodyPr wrap="square" lIns="0" rIns="0" tIns="0" bIns="0" anchor="t">
+          <a:bodyPr wrap="square" lIns="0" tIns="0" rIns="0" bIns="0" anchor="t">
             <a:spAutoFit/>
           </a:bodyPr>
           <a:lstStyle/>
@@ -10220,29 +10488,47 @@
         </p:nvSpPr>
         <p:spPr>
           <a:xfrm>
-            <a:off x="8037576" y="2679700"/>
-            <a:ext cx="2203704" cy="237744"/>
-          </a:xfrm>
-          <a:prstGeom prst="rect">
-            <a:avLst/>
-          </a:prstGeom>
-          <a:noFill/>
-        </p:spPr>
-        <p:txBody>
-          <a:bodyPr wrap="square" lIns="0" rIns="0" tIns="0" bIns="0" anchor="ctr">
+            <a:off x="8037576" y="2706239"/>
+            <a:ext cx="2203704" cy="184666"/>
+          </a:xfrm>
+          <a:prstGeom prst="rect">
+            <a:avLst/>
+          </a:prstGeom>
+          <a:noFill/>
+        </p:spPr>
+        <p:txBody>
+          <a:bodyPr wrap="square" lIns="0" tIns="0" rIns="0" bIns="0" anchor="ctr">
             <a:spAutoFit/>
           </a:bodyPr>
           <a:lstStyle/>
           <a:p>
             <a:pPr algn="l"/>
             <a:r>
-              <a:rPr sz="1200" b="1">
+              <a:rPr sz="1200" b="1" dirty="0">
                 <a:solidFill>
                   <a:srgbClr val="0B57C2"/>
                 </a:solidFill>
                 <a:latin typeface="Arial"/>
               </a:rPr>
-              <a:t>Rp169 T</a:t>
+              <a:t>Rp</a:t>
+            </a:r>
+            <a:r>
+              <a:rPr lang="en-US" sz="1200" b="1" dirty="0">
+                <a:solidFill>
+                  <a:srgbClr val="0B57C2"/>
+                </a:solidFill>
+                <a:latin typeface="Arial"/>
+              </a:rPr>
+              <a:t> XXX </a:t>
+            </a:r>
+            <a:r>
+              <a:rPr sz="1200" b="1" dirty="0">
+                <a:solidFill>
+                  <a:srgbClr val="0B57C2"/>
+                </a:solidFill>
+                <a:latin typeface="Arial"/>
+              </a:rPr>
+              <a:t>T</a:t>
             </a:r>
           </a:p>
         </p:txBody>
@@ -10264,7 +10550,7 @@
           <a:noFill/>
         </p:spPr>
         <p:txBody>
-          <a:bodyPr wrap="square" lIns="0" rIns="0" tIns="0" bIns="0" anchor="t">
+          <a:bodyPr wrap="square" lIns="0" tIns="0" rIns="0" bIns="0" anchor="t">
             <a:spAutoFit/>
           </a:bodyPr>
           <a:lstStyle/>
@@ -10299,21 +10585,36 @@
           <a:noFill/>
         </p:spPr>
         <p:txBody>
-          <a:bodyPr wrap="square" lIns="0" rIns="0" tIns="0" bIns="0" anchor="ctr">
+          <a:bodyPr wrap="square" lIns="0" tIns="0" rIns="0" bIns="0" anchor="ctr">
             <a:spAutoFit/>
           </a:bodyPr>
           <a:lstStyle/>
           <a:p>
             <a:pPr algn="l"/>
             <a:r>
-              <a:rPr sz="1200" b="1">
+              <a:rPr sz="1200" b="1" dirty="0">
                 <a:solidFill>
                   <a:srgbClr val="0B57C2"/>
                 </a:solidFill>
                 <a:latin typeface="Arial"/>
               </a:rPr>
-              <a:t>US$2,4–7,2 miliar</a:t>
-            </a:r>
+              <a:t>US$2,4–7,2 </a:t>
+            </a:r>
+            <a:r>
+              <a:rPr sz="1200" b="1" dirty="0" err="1">
+                <a:solidFill>
+                  <a:srgbClr val="0B57C2"/>
+                </a:solidFill>
+                <a:latin typeface="Arial"/>
+              </a:rPr>
+              <a:t>miliar</a:t>
+            </a:r>
+            <a:endParaRPr sz="1200" b="1" dirty="0">
+              <a:solidFill>
+                <a:srgbClr val="0B57C2"/>
+              </a:solidFill>
+              <a:latin typeface="Arial"/>
+            </a:endParaRPr>
           </a:p>
         </p:txBody>
       </p:sp>
@@ -10334,7 +10635,7 @@
           <a:noFill/>
         </p:spPr>
         <p:txBody>
-          <a:bodyPr wrap="square" lIns="0" rIns="0" tIns="0" bIns="0" anchor="t">
+          <a:bodyPr wrap="square" lIns="0" tIns="0" rIns="0" bIns="0" anchor="t">
             <a:spAutoFit/>
           </a:bodyPr>
           <a:lstStyle/>
@@ -10369,7 +10670,7 @@
           <a:noFill/>
         </p:spPr>
         <p:txBody>
-          <a:bodyPr wrap="square" lIns="0" rIns="0" tIns="0" bIns="0" anchor="t">
+          <a:bodyPr wrap="square" lIns="0" tIns="0" rIns="0" bIns="0" anchor="t">
             <a:spAutoFit/>
           </a:bodyPr>
           <a:lstStyle/>
@@ -10404,7 +10705,7 @@
           <a:noFill/>
         </p:spPr>
         <p:txBody>
-          <a:bodyPr wrap="square" lIns="0" rIns="0" tIns="0" bIns="0" anchor="ctr">
+          <a:bodyPr wrap="square" lIns="0" tIns="0" rIns="0" bIns="0" anchor="ctr">
             <a:spAutoFit/>
           </a:bodyPr>
           <a:lstStyle/>
@@ -10439,7 +10740,7 @@
           <a:noFill/>
         </p:spPr>
         <p:txBody>
-          <a:bodyPr wrap="square" lIns="0" rIns="0" tIns="0" bIns="0" anchor="t">
+          <a:bodyPr wrap="square" lIns="0" tIns="0" rIns="0" bIns="0" anchor="t">
             <a:spAutoFit/>
           </a:bodyPr>
           <a:lstStyle/>
@@ -10474,7 +10775,7 @@
           <a:noFill/>
         </p:spPr>
         <p:txBody>
-          <a:bodyPr wrap="square" lIns="0" rIns="0" tIns="0" bIns="0" anchor="ctr">
+          <a:bodyPr wrap="square" lIns="0" tIns="0" rIns="0" bIns="0" anchor="ctr">
             <a:spAutoFit/>
           </a:bodyPr>
           <a:lstStyle/>
@@ -10509,7 +10810,7 @@
           <a:noFill/>
         </p:spPr>
         <p:txBody>
-          <a:bodyPr wrap="square" lIns="0" rIns="0" tIns="0" bIns="0" anchor="t">
+          <a:bodyPr wrap="square" lIns="0" tIns="0" rIns="0" bIns="0" anchor="t">
             <a:spAutoFit/>
           </a:bodyPr>
           <a:lstStyle/>
@@ -10544,7 +10845,7 @@
           <a:noFill/>
         </p:spPr>
         <p:txBody>
-          <a:bodyPr wrap="square" lIns="0" rIns="0" tIns="0" bIns="0" anchor="ctr">
+          <a:bodyPr wrap="square" lIns="0" tIns="0" rIns="0" bIns="0" anchor="ctr">
             <a:spAutoFit/>
           </a:bodyPr>
           <a:lstStyle/>
@@ -10579,7 +10880,7 @@
           <a:noFill/>
         </p:spPr>
         <p:txBody>
-          <a:bodyPr wrap="square" lIns="0" rIns="0" tIns="0" bIns="0" anchor="t">
+          <a:bodyPr wrap="square" lIns="0" tIns="0" rIns="0" bIns="0" anchor="t">
             <a:spAutoFit/>
           </a:bodyPr>
           <a:lstStyle/>
@@ -10597,42 +10898,6 @@
           </a:p>
         </p:txBody>
       </p:sp>
-      <p:cxnSp>
-        <p:nvCxnSpPr>
-          <p:cNvPr id="77" name="Connector 76"/>
-          <p:cNvCxnSpPr/>
-          <p:nvPr/>
-        </p:nvCxnSpPr>
-        <p:spPr>
-          <a:xfrm>
-            <a:off x="1874519" y="1930400"/>
-            <a:ext cx="320041" cy="0"/>
-          </a:xfrm>
-          <a:prstGeom prst="line">
-            <a:avLst/>
-          </a:prstGeom>
-          <a:ln w="15875">
-            <a:solidFill>
-              <a:srgbClr val="5A6472"/>
-            </a:solidFill>
-            <a:tailEnd type="triangle" w="med" len="med"/>
-          </a:ln>
-        </p:spPr>
-        <p:style>
-          <a:lnRef idx="2">
-            <a:schemeClr val="accent1"/>
-          </a:lnRef>
-          <a:fillRef idx="0">
-            <a:schemeClr val="accent1"/>
-          </a:fillRef>
-          <a:effectRef idx="1">
-            <a:schemeClr val="accent1"/>
-          </a:effectRef>
-          <a:fontRef idx="minor">
-            <a:schemeClr val="tx1"/>
-          </a:fontRef>
-        </p:style>
-      </p:cxnSp>
       <p:cxnSp>
         <p:nvCxnSpPr>
           <p:cNvPr id="78" name="Connector 77"/>
@@ -11319,12 +11584,14 @@
       <p:cxnSp>
         <p:nvCxnSpPr>
           <p:cNvPr id="97" name="Connector 96"/>
-          <p:cNvCxnSpPr/>
+          <p:cNvCxnSpPr>
+            <a:cxnSpLocks/>
+          </p:cNvCxnSpPr>
           <p:nvPr/>
         </p:nvCxnSpPr>
         <p:spPr>
           <a:xfrm flipH="1">
-            <a:off x="3017520" y="1261872"/>
+            <a:off x="3017520" y="972703"/>
             <a:ext cx="6121908" cy="0"/>
           </a:xfrm>
           <a:prstGeom prst="line">
@@ -11360,7 +11627,7 @@
         </p:nvCxnSpPr>
         <p:spPr>
           <a:xfrm>
-            <a:off x="3017520" y="1261872"/>
+            <a:off x="3017520" y="949254"/>
             <a:ext cx="0" cy="256032"/>
           </a:xfrm>
           <a:prstGeom prst="line">
@@ -11432,7 +11699,9 @@
         <p:txBody>
           <a:bodyPr rtlCol="0" anchor="ctr"/>
           <a:lstStyle/>
-          <a:p/>
+          <a:p>
+            <a:endParaRPr/>
+          </a:p>
         </p:txBody>
       </p:sp>
       <p:pic>
@@ -11476,7 +11745,7 @@
           <a:noFill/>
         </p:spPr>
         <p:txBody>
-          <a:bodyPr wrap="square" lIns="0" rIns="0" tIns="0" bIns="0" anchor="ctr">
+          <a:bodyPr wrap="square" lIns="0" tIns="0" rIns="0" bIns="0" anchor="ctr">
             <a:spAutoFit/>
           </a:bodyPr>
           <a:lstStyle/>
@@ -11511,7 +11780,7 @@
           <a:noFill/>
         </p:spPr>
         <p:txBody>
-          <a:bodyPr wrap="square" lIns="0" rIns="0" tIns="0" bIns="0" anchor="t">
+          <a:bodyPr wrap="square" lIns="0" tIns="0" rIns="0" bIns="0" anchor="t">
             <a:spAutoFit/>
           </a:bodyPr>
           <a:lstStyle/>
@@ -11546,7 +11815,7 @@
           <a:noFill/>
         </p:spPr>
         <p:txBody>
-          <a:bodyPr wrap="square" lIns="0" rIns="0" tIns="0" bIns="0" anchor="t">
+          <a:bodyPr wrap="square" lIns="0" tIns="0" rIns="0" bIns="0" anchor="t">
             <a:spAutoFit/>
           </a:bodyPr>
           <a:lstStyle/>
@@ -11607,7 +11876,9 @@
         <p:txBody>
           <a:bodyPr rtlCol="0" anchor="ctr"/>
           <a:lstStyle/>
-          <a:p/>
+          <a:p>
+            <a:endParaRPr/>
+          </a:p>
         </p:txBody>
       </p:sp>
       <p:sp>
@@ -11651,7 +11922,9 @@
         <p:txBody>
           <a:bodyPr rtlCol="0" anchor="ctr"/>
           <a:lstStyle/>
-          <a:p/>
+          <a:p>
+            <a:endParaRPr/>
+          </a:p>
         </p:txBody>
       </p:sp>
       <p:pic>
@@ -11695,7 +11968,7 @@
           <a:noFill/>
         </p:spPr>
         <p:txBody>
-          <a:bodyPr wrap="square" lIns="0" rIns="0" tIns="0" bIns="0" anchor="ctr">
+          <a:bodyPr wrap="square" lIns="0" tIns="0" rIns="0" bIns="0" anchor="ctr">
             <a:spAutoFit/>
           </a:bodyPr>
           <a:lstStyle/>
@@ -11766,7 +12039,9 @@
         <p:txBody>
           <a:bodyPr rtlCol="0" anchor="ctr"/>
           <a:lstStyle/>
-          <a:p/>
+          <a:p>
+            <a:endParaRPr/>
+          </a:p>
         </p:txBody>
       </p:sp>
       <p:sp>
@@ -11786,7 +12061,7 @@
           <a:noFill/>
         </p:spPr>
         <p:txBody>
-          <a:bodyPr wrap="square" lIns="0" rIns="0" tIns="0" bIns="0" anchor="ctr">
+          <a:bodyPr wrap="square" lIns="0" tIns="0" rIns="0" bIns="0" anchor="ctr">
             <a:spAutoFit/>
           </a:bodyPr>
           <a:lstStyle/>
@@ -11857,7 +12132,9 @@
         <p:txBody>
           <a:bodyPr rtlCol="0" anchor="ctr"/>
           <a:lstStyle/>
-          <a:p/>
+          <a:p>
+            <a:endParaRPr/>
+          </a:p>
         </p:txBody>
       </p:sp>
       <p:sp>
@@ -11877,7 +12154,7 @@
           <a:noFill/>
         </p:spPr>
         <p:txBody>
-          <a:bodyPr wrap="square" lIns="0" rIns="0" tIns="0" bIns="0" anchor="ctr">
+          <a:bodyPr wrap="square" lIns="0" tIns="0" rIns="0" bIns="0" anchor="ctr">
             <a:spAutoFit/>
           </a:bodyPr>
           <a:lstStyle/>
@@ -11903,41 +12180,6 @@
                 <a:latin typeface="Arial"/>
               </a:rPr>
               <a:t>Pengembangan proyek dan industri strategis: menjalankan proyek rinci dan DOCK-UP</a:t>
-            </a:r>
-          </a:p>
-        </p:txBody>
-      </p:sp>
-      <p:sp>
-        <p:nvSpPr>
-          <p:cNvPr id="112" name="TextBox 111"/>
-          <p:cNvSpPr txBox="1"/>
-          <p:nvPr/>
-        </p:nvSpPr>
-        <p:spPr>
-          <a:xfrm>
-            <a:off x="9601200" y="6364224"/>
-            <a:ext cx="685800" cy="658368"/>
-          </a:xfrm>
-          <a:prstGeom prst="rect">
-            <a:avLst/>
-          </a:prstGeom>
-          <a:noFill/>
-        </p:spPr>
-        <p:txBody>
-          <a:bodyPr wrap="square" lIns="0" rIns="0" tIns="0" bIns="0" anchor="ctr">
-            <a:spAutoFit/>
-          </a:bodyPr>
-          <a:lstStyle/>
-          <a:p>
-            <a:pPr algn="l"/>
-            <a:r>
-              <a:rPr sz="700" b="1">
-                <a:solidFill>
-                  <a:srgbClr val="0B57C2"/>
-                </a:solidFill>
-                <a:latin typeface="Arial"/>
-              </a:rPr>
-              <a:t>Manusia memutuskan</a:t>
             </a:r>
           </a:p>
         </p:txBody>
@@ -11983,7 +12225,9 @@
         <p:txBody>
           <a:bodyPr rtlCol="0" anchor="ctr"/>
           <a:lstStyle/>
-          <a:p/>
+          <a:p>
+            <a:endParaRPr/>
+          </a:p>
         </p:txBody>
       </p:sp>
       <p:sp>
@@ -12003,7 +12247,7 @@
           <a:noFill/>
         </p:spPr>
         <p:txBody>
-          <a:bodyPr wrap="square" lIns="0" rIns="0" tIns="0" bIns="0" anchor="ctr">
+          <a:bodyPr wrap="square" lIns="0" tIns="0" rIns="0" bIns="0" anchor="ctr">
             <a:spAutoFit/>
           </a:bodyPr>
           <a:lstStyle/>
@@ -12076,7 +12320,9 @@
         <p:txBody>
           <a:bodyPr rtlCol="0" anchor="ctr"/>
           <a:lstStyle/>
-          <a:p/>
+          <a:p>
+            <a:endParaRPr/>
+          </a:p>
         </p:txBody>
       </p:sp>
       <p:sp>
@@ -12096,7 +12342,7 @@
           <a:noFill/>
         </p:spPr>
         <p:txBody>
-          <a:bodyPr wrap="square" lIns="0" rIns="0" tIns="0" bIns="0" anchor="t">
+          <a:bodyPr wrap="square" lIns="0" tIns="0" rIns="0" bIns="0" anchor="t">
             <a:spAutoFit/>
           </a:bodyPr>
           <a:lstStyle/>
@@ -12176,6 +12422,7 @@
           <a:lstStyle/>
           <a:p>
             <a:pPr algn="ctr"/>
+            <a:endParaRPr/>
           </a:p>
         </p:txBody>
       </p:sp>
@@ -12222,7 +12469,9 @@
         <p:txBody>
           <a:bodyPr rtlCol="0" anchor="ctr"/>
           <a:lstStyle/>
-          <a:p/>
+          <a:p>
+            <a:endParaRPr/>
+          </a:p>
         </p:txBody>
       </p:sp>
       <p:sp>
@@ -12242,7 +12491,7 @@
           <a:noFill/>
         </p:spPr>
         <p:txBody>
-          <a:bodyPr wrap="square" lIns="0" rIns="0" tIns="0" bIns="0" anchor="t">
+          <a:bodyPr wrap="square" lIns="0" tIns="0" rIns="0" bIns="0" anchor="t">
             <a:spAutoFit/>
           </a:bodyPr>
           <a:lstStyle/>
@@ -12322,6 +12571,7 @@
           <a:lstStyle/>
           <a:p>
             <a:pPr algn="ctr"/>
+            <a:endParaRPr/>
           </a:p>
         </p:txBody>
       </p:sp>
@@ -12368,7 +12618,9 @@
         <p:txBody>
           <a:bodyPr rtlCol="0" anchor="ctr"/>
           <a:lstStyle/>
-          <a:p/>
+          <a:p>
+            <a:endParaRPr/>
+          </a:p>
         </p:txBody>
       </p:sp>
       <p:sp>
@@ -12388,7 +12640,7 @@
           <a:noFill/>
         </p:spPr>
         <p:txBody>
-          <a:bodyPr wrap="square" lIns="0" rIns="0" tIns="0" bIns="0" anchor="t">
+          <a:bodyPr wrap="square" lIns="0" tIns="0" rIns="0" bIns="0" anchor="t">
             <a:spAutoFit/>
           </a:bodyPr>
           <a:lstStyle/>
@@ -12468,6 +12720,7 @@
           <a:lstStyle/>
           <a:p>
             <a:pPr algn="ctr"/>
+            <a:endParaRPr/>
           </a:p>
         </p:txBody>
       </p:sp>
@@ -12514,7 +12767,9 @@
         <p:txBody>
           <a:bodyPr rtlCol="0" anchor="ctr"/>
           <a:lstStyle/>
-          <a:p/>
+          <a:p>
+            <a:endParaRPr/>
+          </a:p>
         </p:txBody>
       </p:sp>
       <p:sp>
@@ -12534,7 +12789,7 @@
           <a:noFill/>
         </p:spPr>
         <p:txBody>
-          <a:bodyPr wrap="square" lIns="0" rIns="0" tIns="0" bIns="0" anchor="t">
+          <a:bodyPr wrap="square" lIns="0" tIns="0" rIns="0" bIns="0" anchor="t">
             <a:spAutoFit/>
           </a:bodyPr>
           <a:lstStyle/>
@@ -12590,7 +12845,7 @@
           <a:noFill/>
         </p:spPr>
         <p:txBody>
-          <a:bodyPr wrap="square" lIns="0" rIns="0" tIns="0" bIns="0" anchor="ctr">
+          <a:bodyPr wrap="square" lIns="0" tIns="0" rIns="0" bIns="0" anchor="ctr">
             <a:spAutoFit/>
           </a:bodyPr>
           <a:lstStyle/>
@@ -12620,6 +12875,48 @@
           </a:p>
         </p:txBody>
       </p:sp>
+      <p:cxnSp>
+        <p:nvCxnSpPr>
+          <p:cNvPr id="129" name="Connector 78">
+            <a:extLst>
+              <a:ext uri="{FF2B5EF4-FFF2-40B4-BE49-F238E27FC236}">
+                <a16:creationId xmlns:a16="http://schemas.microsoft.com/office/drawing/2014/main" id="{47805D96-1A35-06F4-1EAD-22A42F1F1896}"/>
+              </a:ext>
+            </a:extLst>
+          </p:cNvPr>
+          <p:cNvCxnSpPr/>
+          <p:nvPr/>
+        </p:nvCxnSpPr>
+        <p:spPr>
+          <a:xfrm>
+            <a:off x="1874518" y="2017346"/>
+            <a:ext cx="2286001" cy="0"/>
+          </a:xfrm>
+          <a:prstGeom prst="line">
+            <a:avLst/>
+          </a:prstGeom>
+          <a:ln w="15875">
+            <a:solidFill>
+              <a:srgbClr val="5A6472"/>
+            </a:solidFill>
+            <a:tailEnd type="triangle" w="med" len="med"/>
+          </a:ln>
+        </p:spPr>
+        <p:style>
+          <a:lnRef idx="2">
+            <a:schemeClr val="accent1"/>
+          </a:lnRef>
+          <a:fillRef idx="0">
+            <a:schemeClr val="accent1"/>
+          </a:fillRef>
+          <a:effectRef idx="1">
+            <a:schemeClr val="accent1"/>
+          </a:effectRef>
+          <a:fontRef idx="minor">
+            <a:schemeClr val="tx1"/>
+          </a:fontRef>
+        </p:style>
+      </p:cxnSp>
     </p:spTree>
   </p:cSld>
   <p:clrMapOvr>
@@ -12629,7 +12926,7 @@
 </file>
 
 <file path=ppt/slides/slide4.xml><?xml version="1.0" encoding="utf-8"?>
-<p:sld xmlns:a="http://schemas.openxmlformats.org/drawingml/2006/main" xmlns:p="http://schemas.openxmlformats.org/presentationml/2006/main" xmlns:r="http://schemas.openxmlformats.org/officeDocument/2006/relationships">
+<p:sld xmlns:a="http://schemas.openxmlformats.org/drawingml/2006/main" xmlns:r="http://schemas.openxmlformats.org/officeDocument/2006/relationships" xmlns:p="http://schemas.openxmlformats.org/presentationml/2006/main">
   <p:cSld>
     <p:spTree>
       <p:nvGrpSpPr>
@@ -12637,7 +12934,14 @@
         <p:cNvGrpSpPr/>
         <p:nvPr/>
       </p:nvGrpSpPr>
-      <p:grpSpPr/>
+      <p:grpSpPr>
+        <a:xfrm>
+          <a:off x="0" y="0"/>
+          <a:ext cx="0" cy="0"/>
+          <a:chOff x="0" y="0"/>
+          <a:chExt cx="0" cy="0"/>
+        </a:xfrm>
+      </p:grpSpPr>
       <p:sp>
         <p:nvSpPr>
           <p:cNvPr id="2" name="Text 0"/>
@@ -12830,7 +13134,9 @@
         <p:txBody>
           <a:bodyPr rtlCol="0" anchor="ctr"/>
           <a:lstStyle/>
-          <a:p/>
+          <a:p>
+            <a:endParaRPr/>
+          </a:p>
         </p:txBody>
       </p:sp>
       <p:sp>
@@ -12850,7 +13156,7 @@
           <a:noFill/>
         </p:spPr>
         <p:txBody>
-          <a:bodyPr wrap="square" lIns="0" rIns="0" tIns="0" bIns="0" anchor="ctr">
+          <a:bodyPr wrap="square" lIns="0" tIns="0" rIns="0" bIns="0" anchor="ctr">
             <a:spAutoFit/>
           </a:bodyPr>
           <a:lstStyle/>
@@ -12885,7 +13191,7 @@
           <a:noFill/>
         </p:spPr>
         <p:txBody>
-          <a:bodyPr wrap="square" lIns="0" rIns="0" tIns="0" bIns="0" anchor="t">
+          <a:bodyPr wrap="square" lIns="0" tIns="0" rIns="0" bIns="0" anchor="t">
             <a:spAutoFit/>
           </a:bodyPr>
           <a:lstStyle/>
@@ -12946,7 +13252,9 @@
         <p:txBody>
           <a:bodyPr rtlCol="0" anchor="ctr"/>
           <a:lstStyle/>
-          <a:p/>
+          <a:p>
+            <a:endParaRPr/>
+          </a:p>
         </p:txBody>
       </p:sp>
       <p:sp>
@@ -12966,7 +13274,7 @@
           <a:noFill/>
         </p:spPr>
         <p:txBody>
-          <a:bodyPr wrap="square" lIns="0" rIns="0" tIns="0" bIns="0" anchor="ctr">
+          <a:bodyPr wrap="square" lIns="0" tIns="0" rIns="0" bIns="0" anchor="ctr">
             <a:spAutoFit/>
           </a:bodyPr>
           <a:lstStyle/>
@@ -13001,7 +13309,7 @@
           <a:noFill/>
         </p:spPr>
         <p:txBody>
-          <a:bodyPr wrap="square" lIns="0" rIns="0" tIns="0" bIns="0" anchor="t">
+          <a:bodyPr wrap="square" lIns="0" tIns="0" rIns="0" bIns="0" anchor="t">
             <a:spAutoFit/>
           </a:bodyPr>
           <a:lstStyle/>
@@ -13062,7 +13370,9 @@
         <p:txBody>
           <a:bodyPr rtlCol="0" anchor="ctr"/>
           <a:lstStyle/>
-          <a:p/>
+          <a:p>
+            <a:endParaRPr/>
+          </a:p>
         </p:txBody>
       </p:sp>
       <p:sp>
@@ -13082,7 +13392,7 @@
           <a:noFill/>
         </p:spPr>
         <p:txBody>
-          <a:bodyPr wrap="square" lIns="0" rIns="0" tIns="0" bIns="0" anchor="ctr">
+          <a:bodyPr wrap="square" lIns="0" tIns="0" rIns="0" bIns="0" anchor="ctr">
             <a:spAutoFit/>
           </a:bodyPr>
           <a:lstStyle/>
@@ -13117,7 +13427,7 @@
           <a:noFill/>
         </p:spPr>
         <p:txBody>
-          <a:bodyPr wrap="square" lIns="0" rIns="0" tIns="0" bIns="0" anchor="t">
+          <a:bodyPr wrap="square" lIns="0" tIns="0" rIns="0" bIns="0" anchor="t">
             <a:spAutoFit/>
           </a:bodyPr>
           <a:lstStyle/>
@@ -13178,7 +13488,9 @@
         <p:txBody>
           <a:bodyPr rtlCol="0" anchor="ctr"/>
           <a:lstStyle/>
-          <a:p/>
+          <a:p>
+            <a:endParaRPr/>
+          </a:p>
         </p:txBody>
       </p:sp>
       <p:sp>
@@ -13198,7 +13510,7 @@
           <a:noFill/>
         </p:spPr>
         <p:txBody>
-          <a:bodyPr wrap="square" lIns="0" rIns="0" tIns="0" bIns="0" anchor="ctr">
+          <a:bodyPr wrap="square" lIns="0" tIns="0" rIns="0" bIns="0" anchor="ctr">
             <a:spAutoFit/>
           </a:bodyPr>
           <a:lstStyle/>
@@ -13233,7 +13545,7 @@
           <a:noFill/>
         </p:spPr>
         <p:txBody>
-          <a:bodyPr wrap="square" lIns="0" rIns="0" tIns="0" bIns="0" anchor="t">
+          <a:bodyPr wrap="square" lIns="0" tIns="0" rIns="0" bIns="0" anchor="t">
             <a:spAutoFit/>
           </a:bodyPr>
           <a:lstStyle/>
@@ -13294,7 +13606,9 @@
         <p:txBody>
           <a:bodyPr rtlCol="0" anchor="ctr"/>
           <a:lstStyle/>
-          <a:p/>
+          <a:p>
+            <a:endParaRPr/>
+          </a:p>
         </p:txBody>
       </p:sp>
       <p:sp>
@@ -13338,7 +13652,9 @@
         <p:txBody>
           <a:bodyPr rtlCol="0" anchor="ctr"/>
           <a:lstStyle/>
-          <a:p/>
+          <a:p>
+            <a:endParaRPr/>
+          </a:p>
         </p:txBody>
       </p:sp>
       <p:pic>
@@ -13382,7 +13698,7 @@
           <a:noFill/>
         </p:spPr>
         <p:txBody>
-          <a:bodyPr wrap="square" lIns="0" rIns="0" tIns="0" bIns="0" anchor="ctr">
+          <a:bodyPr wrap="square" lIns="0" tIns="0" rIns="0" bIns="0" anchor="ctr">
             <a:spAutoFit/>
           </a:bodyPr>
           <a:lstStyle/>
@@ -13417,7 +13733,7 @@
           <a:noFill/>
         </p:spPr>
         <p:txBody>
-          <a:bodyPr wrap="square" lIns="0" rIns="0" tIns="0" bIns="0" anchor="ctr">
+          <a:bodyPr wrap="square" lIns="0" tIns="0" rIns="0" bIns="0" anchor="ctr">
             <a:spAutoFit/>
           </a:bodyPr>
           <a:lstStyle/>
@@ -13452,7 +13768,7 @@
           <a:noFill/>
         </p:spPr>
         <p:txBody>
-          <a:bodyPr wrap="square" lIns="0" rIns="0" tIns="0" bIns="0" anchor="t">
+          <a:bodyPr wrap="square" lIns="0" tIns="0" rIns="0" bIns="0" anchor="t">
             <a:spAutoFit/>
           </a:bodyPr>
           <a:lstStyle/>
@@ -13513,7 +13829,9 @@
         <p:txBody>
           <a:bodyPr rtlCol="0" anchor="ctr"/>
           <a:lstStyle/>
-          <a:p/>
+          <a:p>
+            <a:endParaRPr/>
+          </a:p>
         </p:txBody>
       </p:sp>
       <p:sp>
@@ -13557,7 +13875,9 @@
         <p:txBody>
           <a:bodyPr rtlCol="0" anchor="ctr"/>
           <a:lstStyle/>
-          <a:p/>
+          <a:p>
+            <a:endParaRPr/>
+          </a:p>
         </p:txBody>
       </p:sp>
       <p:pic>
@@ -13601,7 +13921,7 @@
           <a:noFill/>
         </p:spPr>
         <p:txBody>
-          <a:bodyPr wrap="square" lIns="0" rIns="0" tIns="0" bIns="0" anchor="ctr">
+          <a:bodyPr wrap="square" lIns="0" tIns="0" rIns="0" bIns="0" anchor="ctr">
             <a:spAutoFit/>
           </a:bodyPr>
           <a:lstStyle/>
@@ -13636,7 +13956,7 @@
           <a:noFill/>
         </p:spPr>
         <p:txBody>
-          <a:bodyPr wrap="square" lIns="0" rIns="0" tIns="0" bIns="0" anchor="ctr">
+          <a:bodyPr wrap="square" lIns="0" tIns="0" rIns="0" bIns="0" anchor="ctr">
             <a:spAutoFit/>
           </a:bodyPr>
           <a:lstStyle/>
@@ -13671,7 +13991,7 @@
           <a:noFill/>
         </p:spPr>
         <p:txBody>
-          <a:bodyPr wrap="square" lIns="0" rIns="0" tIns="0" bIns="0" anchor="t">
+          <a:bodyPr wrap="square" lIns="0" tIns="0" rIns="0" bIns="0" anchor="t">
             <a:spAutoFit/>
           </a:bodyPr>
           <a:lstStyle/>
@@ -13732,7 +14052,9 @@
         <p:txBody>
           <a:bodyPr rtlCol="0" anchor="ctr"/>
           <a:lstStyle/>
-          <a:p/>
+          <a:p>
+            <a:endParaRPr/>
+          </a:p>
         </p:txBody>
       </p:sp>
       <p:sp>
@@ -13776,7 +14098,9 @@
         <p:txBody>
           <a:bodyPr rtlCol="0" anchor="ctr"/>
           <a:lstStyle/>
-          <a:p/>
+          <a:p>
+            <a:endParaRPr/>
+          </a:p>
         </p:txBody>
       </p:sp>
       <p:pic>
@@ -13820,7 +14144,7 @@
           <a:noFill/>
         </p:spPr>
         <p:txBody>
-          <a:bodyPr wrap="square" lIns="0" rIns="0" tIns="0" bIns="0" anchor="ctr">
+          <a:bodyPr wrap="square" lIns="0" tIns="0" rIns="0" bIns="0" anchor="ctr">
             <a:spAutoFit/>
           </a:bodyPr>
           <a:lstStyle/>
@@ -13855,7 +14179,7 @@
           <a:noFill/>
         </p:spPr>
         <p:txBody>
-          <a:bodyPr wrap="square" lIns="0" rIns="0" tIns="0" bIns="0" anchor="ctr">
+          <a:bodyPr wrap="square" lIns="0" tIns="0" rIns="0" bIns="0" anchor="ctr">
             <a:spAutoFit/>
           </a:bodyPr>
           <a:lstStyle/>
@@ -13890,7 +14214,7 @@
           <a:noFill/>
         </p:spPr>
         <p:txBody>
-          <a:bodyPr wrap="square" lIns="0" rIns="0" tIns="0" bIns="0" anchor="t">
+          <a:bodyPr wrap="square" lIns="0" tIns="0" rIns="0" bIns="0" anchor="t">
             <a:spAutoFit/>
           </a:bodyPr>
           <a:lstStyle/>
@@ -13951,7 +14275,9 @@
         <p:txBody>
           <a:bodyPr rtlCol="0" anchor="ctr"/>
           <a:lstStyle/>
-          <a:p/>
+          <a:p>
+            <a:endParaRPr/>
+          </a:p>
         </p:txBody>
       </p:sp>
       <p:sp>
@@ -13995,7 +14321,9 @@
         <p:txBody>
           <a:bodyPr rtlCol="0" anchor="ctr"/>
           <a:lstStyle/>
-          <a:p/>
+          <a:p>
+            <a:endParaRPr/>
+          </a:p>
         </p:txBody>
       </p:sp>
       <p:pic>
@@ -14039,7 +14367,7 @@
           <a:noFill/>
         </p:spPr>
         <p:txBody>
-          <a:bodyPr wrap="square" lIns="0" rIns="0" tIns="0" bIns="0" anchor="ctr">
+          <a:bodyPr wrap="square" lIns="0" tIns="0" rIns="0" bIns="0" anchor="ctr">
             <a:spAutoFit/>
           </a:bodyPr>
           <a:lstStyle/>
@@ -14074,7 +14402,7 @@
           <a:noFill/>
         </p:spPr>
         <p:txBody>
-          <a:bodyPr wrap="square" lIns="0" rIns="0" tIns="0" bIns="0" anchor="ctr">
+          <a:bodyPr wrap="square" lIns="0" tIns="0" rIns="0" bIns="0" anchor="ctr">
             <a:spAutoFit/>
           </a:bodyPr>
           <a:lstStyle/>
@@ -14109,7 +14437,7 @@
           <a:noFill/>
         </p:spPr>
         <p:txBody>
-          <a:bodyPr wrap="square" lIns="0" rIns="0" tIns="0" bIns="0" anchor="t">
+          <a:bodyPr wrap="square" lIns="0" tIns="0" rIns="0" bIns="0" anchor="t">
             <a:spAutoFit/>
           </a:bodyPr>
           <a:lstStyle/>
@@ -14170,7 +14498,9 @@
         <p:txBody>
           <a:bodyPr rtlCol="0" anchor="ctr"/>
           <a:lstStyle/>
-          <a:p/>
+          <a:p>
+            <a:endParaRPr/>
+          </a:p>
         </p:txBody>
       </p:sp>
       <p:sp>
@@ -14214,7 +14544,9 @@
         <p:txBody>
           <a:bodyPr rtlCol="0" anchor="ctr"/>
           <a:lstStyle/>
-          <a:p/>
+          <a:p>
+            <a:endParaRPr/>
+          </a:p>
         </p:txBody>
       </p:sp>
       <p:pic>
@@ -14258,7 +14590,7 @@
           <a:noFill/>
         </p:spPr>
         <p:txBody>
-          <a:bodyPr wrap="square" lIns="0" rIns="0" tIns="0" bIns="0" anchor="ctr">
+          <a:bodyPr wrap="square" lIns="0" tIns="0" rIns="0" bIns="0" anchor="ctr">
             <a:spAutoFit/>
           </a:bodyPr>
           <a:lstStyle/>
@@ -14293,7 +14625,7 @@
           <a:noFill/>
         </p:spPr>
         <p:txBody>
-          <a:bodyPr wrap="square" lIns="0" rIns="0" tIns="0" bIns="0" anchor="ctr">
+          <a:bodyPr wrap="square" lIns="0" tIns="0" rIns="0" bIns="0" anchor="ctr">
             <a:spAutoFit/>
           </a:bodyPr>
           <a:lstStyle/>
@@ -14328,7 +14660,7 @@
           <a:noFill/>
         </p:spPr>
         <p:txBody>
-          <a:bodyPr wrap="square" lIns="0" rIns="0" tIns="0" bIns="0" anchor="t">
+          <a:bodyPr wrap="square" lIns="0" tIns="0" rIns="0" bIns="0" anchor="t">
             <a:spAutoFit/>
           </a:bodyPr>
           <a:lstStyle/>
@@ -14389,7 +14721,9 @@
         <p:txBody>
           <a:bodyPr rtlCol="0" anchor="ctr"/>
           <a:lstStyle/>
-          <a:p/>
+          <a:p>
+            <a:endParaRPr/>
+          </a:p>
         </p:txBody>
       </p:sp>
       <p:sp>
@@ -14433,7 +14767,9 @@
         <p:txBody>
           <a:bodyPr rtlCol="0" anchor="ctr"/>
           <a:lstStyle/>
-          <a:p/>
+          <a:p>
+            <a:endParaRPr/>
+          </a:p>
         </p:txBody>
       </p:sp>
       <p:pic>
@@ -14477,7 +14813,7 @@
           <a:noFill/>
         </p:spPr>
         <p:txBody>
-          <a:bodyPr wrap="square" lIns="0" rIns="0" tIns="0" bIns="0" anchor="ctr">
+          <a:bodyPr wrap="square" lIns="0" tIns="0" rIns="0" bIns="0" anchor="ctr">
             <a:spAutoFit/>
           </a:bodyPr>
           <a:lstStyle/>
@@ -14512,7 +14848,7 @@
           <a:noFill/>
         </p:spPr>
         <p:txBody>
-          <a:bodyPr wrap="square" lIns="0" rIns="0" tIns="0" bIns="0" anchor="ctr">
+          <a:bodyPr wrap="square" lIns="0" tIns="0" rIns="0" bIns="0" anchor="ctr">
             <a:spAutoFit/>
           </a:bodyPr>
           <a:lstStyle/>
@@ -14547,7 +14883,7 @@
           <a:noFill/>
         </p:spPr>
         <p:txBody>
-          <a:bodyPr wrap="square" lIns="0" rIns="0" tIns="0" bIns="0" anchor="t">
+          <a:bodyPr wrap="square" lIns="0" tIns="0" rIns="0" bIns="0" anchor="t">
             <a:spAutoFit/>
           </a:bodyPr>
           <a:lstStyle/>
@@ -14608,7 +14944,9 @@
         <p:txBody>
           <a:bodyPr rtlCol="0" anchor="ctr"/>
           <a:lstStyle/>
-          <a:p/>
+          <a:p>
+            <a:endParaRPr/>
+          </a:p>
         </p:txBody>
       </p:sp>
       <p:sp>
@@ -14652,7 +14990,9 @@
         <p:txBody>
           <a:bodyPr rtlCol="0" anchor="ctr"/>
           <a:lstStyle/>
-          <a:p/>
+          <a:p>
+            <a:endParaRPr/>
+          </a:p>
         </p:txBody>
       </p:sp>
       <p:pic>
@@ -14696,7 +15036,7 @@
           <a:noFill/>
         </p:spPr>
         <p:txBody>
-          <a:bodyPr wrap="square" lIns="0" rIns="0" tIns="0" bIns="0" anchor="ctr">
+          <a:bodyPr wrap="square" lIns="0" tIns="0" rIns="0" bIns="0" anchor="ctr">
             <a:spAutoFit/>
           </a:bodyPr>
           <a:lstStyle/>
@@ -14731,7 +15071,7 @@
           <a:noFill/>
         </p:spPr>
         <p:txBody>
-          <a:bodyPr wrap="square" lIns="0" rIns="0" tIns="0" bIns="0" anchor="ctr">
+          <a:bodyPr wrap="square" lIns="0" tIns="0" rIns="0" bIns="0" anchor="ctr">
             <a:spAutoFit/>
           </a:bodyPr>
           <a:lstStyle/>
@@ -14766,7 +15106,7 @@
           <a:noFill/>
         </p:spPr>
         <p:txBody>
-          <a:bodyPr wrap="square" lIns="0" rIns="0" tIns="0" bIns="0" anchor="t">
+          <a:bodyPr wrap="square" lIns="0" tIns="0" rIns="0" bIns="0" anchor="t">
             <a:spAutoFit/>
           </a:bodyPr>
           <a:lstStyle/>
@@ -14827,7 +15167,9 @@
         <p:txBody>
           <a:bodyPr rtlCol="0" anchor="ctr"/>
           <a:lstStyle/>
-          <a:p/>
+          <a:p>
+            <a:endParaRPr/>
+          </a:p>
         </p:txBody>
       </p:sp>
       <p:sp>
@@ -14871,7 +15213,9 @@
         <p:txBody>
           <a:bodyPr rtlCol="0" anchor="ctr"/>
           <a:lstStyle/>
-          <a:p/>
+          <a:p>
+            <a:endParaRPr/>
+          </a:p>
         </p:txBody>
       </p:sp>
       <p:pic>
@@ -14915,7 +15259,7 @@
           <a:noFill/>
         </p:spPr>
         <p:txBody>
-          <a:bodyPr wrap="square" lIns="0" rIns="0" tIns="0" bIns="0" anchor="ctr">
+          <a:bodyPr wrap="square" lIns="0" tIns="0" rIns="0" bIns="0" anchor="ctr">
             <a:spAutoFit/>
           </a:bodyPr>
           <a:lstStyle/>
@@ -14950,7 +15294,7 @@
           <a:noFill/>
         </p:spPr>
         <p:txBody>
-          <a:bodyPr wrap="square" lIns="0" rIns="0" tIns="0" bIns="0" anchor="ctr">
+          <a:bodyPr wrap="square" lIns="0" tIns="0" rIns="0" bIns="0" anchor="ctr">
             <a:spAutoFit/>
           </a:bodyPr>
           <a:lstStyle/>
@@ -14985,7 +15329,7 @@
           <a:noFill/>
         </p:spPr>
         <p:txBody>
-          <a:bodyPr wrap="square" lIns="0" rIns="0" tIns="0" bIns="0" anchor="t">
+          <a:bodyPr wrap="square" lIns="0" tIns="0" rIns="0" bIns="0" anchor="t">
             <a:spAutoFit/>
           </a:bodyPr>
           <a:lstStyle/>
@@ -15020,7 +15364,7 @@
           <a:noFill/>
         </p:spPr>
         <p:txBody>
-          <a:bodyPr wrap="square" lIns="0" rIns="0" tIns="0" bIns="0" anchor="t">
+          <a:bodyPr wrap="square" lIns="0" tIns="0" rIns="0" bIns="0" anchor="t">
             <a:spAutoFit/>
           </a:bodyPr>
           <a:lstStyle/>

</xml_diff>